<commit_message>
fix: endpoint guard hardening + run reopen (§79a-e, prior session's work)
Committing the tested-but-uncommitted state left by the previous
session so the holistic scheduler rework can build on a clean base:
per-device asyncio lock around ensure_worker's check-then-act gap,
tunnel probe in the READY liveness check, no-start-on-RUNNING routing,
busy-guard verification against Nebius's real state, start retry when
the poll loop observes STOPPED, stop_training releasing mid-flight
worker sessions, idle-clock reset on (re)provision, terminal-run
reopen with Completed filter. Backend 234 passed, frontend 79 passed
as left by that session.

Co-Authored-By: Claude Fable 5 <noreply@anthropic.com>
</commit_message>
<xml_diff>
--- a/presentation/LLM_Experiments_Lab.pptx
+++ b/presentation/LLM_Experiments_Lab.pptx
@@ -4,18 +4,17 @@
   <p:sldMasterIdLst>
     <p:sldMasterId id="2147483648" r:id="rId1"/>
   </p:sldMasterIdLst>
+  <p:notesMasterIdLst>
+    <p:notesMasterId r:id="rId7"/>
+  </p:notesMasterIdLst>
   <p:sldIdLst>
     <p:sldId id="256" r:id="rId2"/>
     <p:sldId id="257" r:id="rId3"/>
     <p:sldId id="258" r:id="rId4"/>
     <p:sldId id="259" r:id="rId5"/>
-    <p:sldId id="260" r:id="rId6"/>
-    <p:sldId id="261" r:id="rId7"/>
+    <p:sldId id="261" r:id="rId6"/>
   </p:sldIdLst>
-  <p:notesMasterIdLst>
-    <p:notesMasterId r:id="rId8"/>
-  </p:notesMasterIdLst>
-  <p:sldSz cx="9144000" cy="5143500"/>
+  <p:sldSz cx="9144000" cy="5143500" type="screen16x9"/>
   <p:notesSz cx="5143500" cy="9144000"/>
   <p:defaultTextStyle>
     <a:lvl1pPr marL="0" algn="l" defTabSz="914400" rtl="0" eaLnBrk="1" latinLnBrk="0" hangingPunct="1">
@@ -109,6 +108,11 @@
       </a:defRPr>
     </a:lvl9pPr>
   </p:defaultTextStyle>
+  <p:extLst>
+    <p:ext uri="{EFAFB233-063F-42B5-8137-9DF3F51BA10A}">
+      <p15:sldGuideLst xmlns:p15="http://schemas.microsoft.com/office/powerpoint/2012/main"/>
+    </p:ext>
+  </p:extLst>
 </p:presentation>
 </file>
 
@@ -134,234 +138,10 @@
           <a:chExt cx="0" cy="0"/>
         </a:xfrm>
       </p:grpSpPr>
-      <p:sp>
-        <p:nvSpPr>
-          <p:cNvPr id="2" name="Header Placeholder 1"/>
-          <p:cNvSpPr>
-            <a:spLocks noGrp="1"/>
-          </p:cNvSpPr>
-          <p:nvPr>
-            <p:ph type="hdr" sz="quarter"/>
-          </p:nvPr>
-        </p:nvSpPr>
-        <p:spPr>
-          <a:xfrm>
-            <a:off x="0" y="0"/>
-            <a:ext cx="2971800" cy="458788"/>
-          </a:xfrm>
-          <a:prstGeom prst="rect">
-            <a:avLst/>
-          </a:prstGeom>
-        </p:spPr>
-        <p:txBody>
-          <a:bodyPr vert="horz" lIns="91440" tIns="45720" rIns="91440" bIns="45720" rtlCol="0"/>
-          <a:lstStyle>
-            <a:lvl1pPr algn="l">
-              <a:defRPr sz="1200"/>
-            </a:lvl1pPr>
-          </a:lstStyle>
-          <a:p>
-            <a:endParaRPr lang="en-US"/>
-          </a:p>
-        </p:txBody>
-      </p:sp>
-      <p:sp>
-        <p:nvSpPr>
-          <p:cNvPr id="3" name="Date Placeholder 2"/>
-          <p:cNvSpPr>
-            <a:spLocks noGrp="1"/>
-          </p:cNvSpPr>
-          <p:nvPr>
-            <p:ph type="dt" idx="1"/>
-          </p:nvPr>
-        </p:nvSpPr>
-        <p:spPr>
-          <a:xfrm>
-            <a:off x="3884613" y="0"/>
-            <a:ext cx="2971800" cy="458788"/>
-          </a:xfrm>
-          <a:prstGeom prst="rect">
-            <a:avLst/>
-          </a:prstGeom>
-        </p:spPr>
-        <p:txBody>
-          <a:bodyPr vert="horz" lIns="91440" tIns="45720" rIns="91440" bIns="45720" rtlCol="0"/>
-          <a:lstStyle>
-            <a:lvl1pPr algn="r">
-              <a:defRPr sz="1200"/>
-            </a:lvl1pPr>
-          </a:lstStyle>
-          <a:p>
-            <a:fld id="{5282F153-3F37-0F45-9E97-73ACFA13230C}" type="datetimeFigureOut">
-              <a:rPr lang="en-US"/>
-              <a:t>7/23/19</a:t>
-            </a:fld>
-            <a:endParaRPr lang="en-US"/>
-          </a:p>
-        </p:txBody>
-      </p:sp>
-      <p:sp>
-        <p:nvSpPr>
-          <p:cNvPr id="4" name="Slide Image Placeholder 3"/>
-          <p:cNvSpPr>
-            <a:spLocks noGrp="1" noRot="1" noChangeAspect="1"/>
-          </p:cNvSpPr>
-          <p:nvPr>
-            <p:ph type="sldImg" idx="2"/>
-          </p:nvPr>
-        </p:nvSpPr>
-        <p:spPr>
-          <a:xfrm>
-            <a:off x="685800" y="1143000"/>
-            <a:ext cx="5486400" cy="3086100"/>
-          </a:xfrm>
-          <a:prstGeom prst="rect">
-            <a:avLst/>
-          </a:prstGeom>
-          <a:noFill/>
-          <a:ln w="12700">
-            <a:solidFill>
-              <a:prstClr val="black"/>
-            </a:solidFill>
-          </a:ln>
-        </p:spPr>
-        <p:txBody>
-          <a:bodyPr vert="horz" lIns="91440" tIns="45720" rIns="91440" bIns="45720" rtlCol="0" anchor="ctr"/>
-          <a:lstStyle/>
-          <a:p>
-            <a:endParaRPr lang="en-US"/>
-          </a:p>
-        </p:txBody>
-      </p:sp>
-      <p:sp>
-        <p:nvSpPr>
-          <p:cNvPr id="5" name="Notes Placeholder 4"/>
-          <p:cNvSpPr>
-            <a:spLocks noGrp="1"/>
-          </p:cNvSpPr>
-          <p:nvPr>
-            <p:ph type="body" sz="quarter" idx="3"/>
-          </p:nvPr>
-        </p:nvSpPr>
-        <p:spPr>
-          <a:xfrm>
-            <a:off x="685800" y="4400550"/>
-            <a:ext cx="5486400" cy="3600450"/>
-          </a:xfrm>
-          <a:prstGeom prst="rect">
-            <a:avLst/>
-          </a:prstGeom>
-        </p:spPr>
-        <p:txBody>
-          <a:bodyPr vert="horz" lIns="91440" tIns="45720" rIns="91440" bIns="45720" rtlCol="0"/>
-          <a:lstStyle/>
-          <a:p>
-            <a:pPr lvl="0"/>
-            <a:r>
-              <a:rPr lang="en-US"/>
-              <a:t>Click to edit Master text styles</a:t>
-            </a:r>
-          </a:p>
-          <a:p>
-            <a:pPr lvl="1"/>
-            <a:r>
-              <a:rPr lang="en-US"/>
-              <a:t>Second level</a:t>
-            </a:r>
-          </a:p>
-          <a:p>
-            <a:pPr lvl="2"/>
-            <a:r>
-              <a:rPr lang="en-US"/>
-              <a:t>Third level</a:t>
-            </a:r>
-          </a:p>
-          <a:p>
-            <a:pPr lvl="3"/>
-            <a:r>
-              <a:rPr lang="en-US"/>
-              <a:t>Fourth level</a:t>
-            </a:r>
-          </a:p>
-          <a:p>
-            <a:pPr lvl="4"/>
-            <a:r>
-              <a:rPr lang="en-US"/>
-              <a:t>Fifth level</a:t>
-            </a:r>
-          </a:p>
-        </p:txBody>
-      </p:sp>
-      <p:sp>
-        <p:nvSpPr>
-          <p:cNvPr id="6" name="Footer Placeholder 5"/>
-          <p:cNvSpPr>
-            <a:spLocks noGrp="1"/>
-          </p:cNvSpPr>
-          <p:nvPr>
-            <p:ph type="ftr" sz="quarter" idx="4"/>
-          </p:nvPr>
-        </p:nvSpPr>
-        <p:spPr>
-          <a:xfrm>
-            <a:off x="0" y="8685213"/>
-            <a:ext cx="2971800" cy="458787"/>
-          </a:xfrm>
-          <a:prstGeom prst="rect">
-            <a:avLst/>
-          </a:prstGeom>
-        </p:spPr>
-        <p:txBody>
-          <a:bodyPr vert="horz" lIns="91440" tIns="45720" rIns="91440" bIns="45720" rtlCol="0" anchor="b"/>
-          <a:lstStyle>
-            <a:lvl1pPr algn="l">
-              <a:defRPr sz="1200"/>
-            </a:lvl1pPr>
-          </a:lstStyle>
-          <a:p>
-            <a:endParaRPr lang="en-US"/>
-          </a:p>
-        </p:txBody>
-      </p:sp>
-      <p:sp>
-        <p:nvSpPr>
-          <p:cNvPr id="7" name="Slide Number Placeholder 6"/>
-          <p:cNvSpPr>
-            <a:spLocks noGrp="1"/>
-          </p:cNvSpPr>
-          <p:nvPr>
-            <p:ph type="sldNum" sz="quarter" idx="5"/>
-          </p:nvPr>
-        </p:nvSpPr>
-        <p:spPr>
-          <a:xfrm>
-            <a:off x="3884613" y="8685213"/>
-            <a:ext cx="2971800" cy="458787"/>
-          </a:xfrm>
-          <a:prstGeom prst="rect">
-            <a:avLst/>
-          </a:prstGeom>
-        </p:spPr>
-        <p:txBody>
-          <a:bodyPr vert="horz" lIns="91440" tIns="45720" rIns="91440" bIns="45720" rtlCol="0" anchor="b"/>
-          <a:lstStyle>
-            <a:lvl1pPr algn="r">
-              <a:defRPr sz="1200"/>
-            </a:lvl1pPr>
-          </a:lstStyle>
-          <a:p>
-            <a:fld id="{CE5E9CC1-C706-0F49-92D6-E571CC5EEA8F}" type="slidenum">
-              <a:rPr lang="en-US"/>
-              <a:t>‹#›</a:t>
-            </a:fld>
-            <a:endParaRPr lang="en-US"/>
-          </a:p>
-        </p:txBody>
-      </p:sp>
     </p:spTree>
     <p:extLst>
       <p:ext uri="{BB962C8B-B14F-4D97-AF65-F5344CB8AC3E}">
-        <p14:creationId xmlns:p14="http://schemas.microsoft.com/office/powerpoint/2010/main" val="1024086991"/>
+        <p14:creationId xmlns:p14="http://schemas.microsoft.com/office/powerpoint/2010/main" val="1563468247"/>
       </p:ext>
     </p:extLst>
   </p:cSld>
@@ -505,10 +285,6 @@
           <a:bodyPr/>
           <a:lstStyle/>
           <a:p>
-            <a:r>
-              <a:rPr lang="en-US" dirty="0"/>
-              <a:t/>
-            </a:r>
             <a:endParaRPr lang="en-US" dirty="0"/>
           </a:p>
         </p:txBody>
@@ -593,10 +369,6 @@
           <a:bodyPr/>
           <a:lstStyle/>
           <a:p>
-            <a:r>
-              <a:rPr lang="en-US" dirty="0"/>
-              <a:t/>
-            </a:r>
             <a:endParaRPr lang="en-US" dirty="0"/>
           </a:p>
         </p:txBody>
@@ -681,10 +453,6 @@
           <a:bodyPr/>
           <a:lstStyle/>
           <a:p>
-            <a:r>
-              <a:rPr lang="en-US" dirty="0"/>
-              <a:t/>
-            </a:r>
             <a:endParaRPr lang="en-US" dirty="0"/>
           </a:p>
         </p:txBody>
@@ -769,10 +537,6 @@
           <a:bodyPr/>
           <a:lstStyle/>
           <a:p>
-            <a:r>
-              <a:rPr lang="en-US" dirty="0"/>
-              <a:t/>
-            </a:r>
             <a:endParaRPr lang="en-US" dirty="0"/>
           </a:p>
         </p:txBody>
@@ -857,10 +621,6 @@
           <a:bodyPr/>
           <a:lstStyle/>
           <a:p>
-            <a:r>
-              <a:rPr lang="en-US" dirty="0"/>
-              <a:t/>
-            </a:r>
             <a:endParaRPr lang="en-US" dirty="0"/>
           </a:p>
         </p:txBody>
@@ -883,94 +643,6 @@
             <a:fld id="{F7021451-1387-4CA6-816F-3879F97B5CBC}" type="slidenum">
               <a:rPr lang="en-US"/>
               <a:t>5</a:t>
-            </a:fld>
-            <a:endParaRPr lang="en-US"/>
-          </a:p>
-        </p:txBody>
-      </p:sp>
-    </p:spTree>
-    <p:extLst>
-      <p:ext uri="{BB962C8B-B14F-4D97-AF65-F5344CB8AC3E}">
-        <p14:creationId xmlns:p14="http://schemas.microsoft.com/office/powerpoint/2010/main" val="1024086991"/>
-      </p:ext>
-    </p:extLst>
-  </p:cSld>
-  <p:clrMapOvr>
-    <a:masterClrMapping/>
-  </p:clrMapOvr>
-</p:notes>
-</file>
-
-<file path=ppt/notesSlides/notesSlide6.xml><?xml version="1.0" encoding="utf-8"?>
-<p:notes xmlns:a="http://schemas.openxmlformats.org/drawingml/2006/main" xmlns:r="http://schemas.openxmlformats.org/officeDocument/2006/relationships" xmlns:p="http://schemas.openxmlformats.org/presentationml/2006/main">
-  <p:cSld>
-    <p:spTree>
-      <p:nvGrpSpPr>
-        <p:cNvPr id="1" name=""/>
-        <p:cNvGrpSpPr/>
-        <p:nvPr/>
-      </p:nvGrpSpPr>
-      <p:grpSpPr>
-        <a:xfrm>
-          <a:off x="0" y="0"/>
-          <a:ext cx="0" cy="0"/>
-          <a:chOff x="0" y="0"/>
-          <a:chExt cx="0" cy="0"/>
-        </a:xfrm>
-      </p:grpSpPr>
-      <p:sp>
-        <p:nvSpPr>
-          <p:cNvPr id="2" name="Slide Image Placeholder 1"/>
-          <p:cNvSpPr>
-            <a:spLocks noGrp="1" noRot="1" noChangeAspect="1"/>
-          </p:cNvSpPr>
-          <p:nvPr>
-            <p:ph type="sldImg"/>
-          </p:nvPr>
-        </p:nvSpPr>
-        <p:spPr/>
-      </p:sp>
-      <p:sp>
-        <p:nvSpPr>
-          <p:cNvPr id="3" name="Notes Placeholder 2"/>
-          <p:cNvSpPr>
-            <a:spLocks noGrp="1"/>
-          </p:cNvSpPr>
-          <p:nvPr>
-            <p:ph type="body" idx="1"/>
-          </p:nvPr>
-        </p:nvSpPr>
-        <p:spPr/>
-        <p:txBody>
-          <a:bodyPr/>
-          <a:lstStyle/>
-          <a:p>
-            <a:r>
-              <a:rPr lang="en-US" dirty="0"/>
-              <a:t/>
-            </a:r>
-            <a:endParaRPr lang="en-US" dirty="0"/>
-          </a:p>
-        </p:txBody>
-      </p:sp>
-      <p:sp>
-        <p:nvSpPr>
-          <p:cNvPr id="4" name="Slide Number Placeholder 3"/>
-          <p:cNvSpPr>
-            <a:spLocks noGrp="1"/>
-          </p:cNvSpPr>
-          <p:nvPr>
-            <p:ph type="sldNum" sz="quarter" idx="10"/>
-          </p:nvPr>
-        </p:nvSpPr>
-        <p:spPr/>
-        <p:txBody>
-          <a:bodyPr/>
-          <a:lstStyle/>
-          <a:p>
-            <a:fld id="{F7021451-1387-4CA6-816F-3879F97B5CBC}" type="slidenum">
-              <a:rPr lang="en-US"/>
-              <a:t>6</a:t>
             </a:fld>
             <a:endParaRPr lang="en-US"/>
           </a:p>
@@ -1022,6 +694,11 @@
 <file path=ppt/slideMasters/slideMaster1.xml><?xml version="1.0" encoding="utf-8"?>
 <p:sldMaster xmlns:a="http://schemas.openxmlformats.org/drawingml/2006/main" xmlns:r="http://schemas.openxmlformats.org/officeDocument/2006/relationships" xmlns:p="http://schemas.openxmlformats.org/presentationml/2006/main">
   <p:cSld>
+    <p:bg>
+      <p:bgRef idx="1001">
+        <a:schemeClr val="bg1"/>
+      </p:bgRef>
+    </p:bg>
     <p:spTree>
       <p:nvGrpSpPr>
         <p:cNvPr id="1" name=""/>
@@ -1304,6 +981,7 @@
         <a:solidFill>
           <a:srgbClr val="0F172A"/>
         </a:solidFill>
+        <a:effectLst/>
       </p:bgPr>
     </p:bg>
     <p:spTree>
@@ -1341,7 +1019,7 @@
           <a:bodyPr wrap="square" lIns="0" tIns="0" rIns="0" bIns="0" rtlCol="0" anchor="t"/>
           <a:lstStyle/>
           <a:p>
-            <a:pPr algn="l" indent="0" marL="0">
+            <a:pPr marL="0" indent="0" algn="l">
               <a:spcBef>
                 <a:spcPts val="1200"/>
               </a:spcBef>
@@ -1386,7 +1064,7 @@
           <a:bodyPr wrap="square" lIns="0" tIns="0" rIns="0" bIns="0" rtlCol="0" anchor="t"/>
           <a:lstStyle/>
           <a:p>
-            <a:pPr algn="l" indent="0" marL="0">
+            <a:pPr marL="0" indent="0" algn="l">
               <a:lnSpc>
                 <a:spcPts val="3600"/>
               </a:lnSpc>
@@ -1404,7 +1082,7 @@
                 <a:ea typeface="Arial" pitchFamily="34" charset="-122"/>
                 <a:cs typeface="Arial" pitchFamily="34" charset="-120"/>
               </a:rPr>
-              <a:t>What if you could pause a language model mid-thought and just... ask it what it knows?</a:t>
+              <a:t>What if you could pause a language model mid-thought and just... ask it what it is thinking?</a:t>
             </a:r>
             <a:endParaRPr lang="en-US" sz="3000" dirty="0"/>
           </a:p>
@@ -1439,7 +1117,7 @@
           <a:bodyPr wrap="square" rtlCol="0" anchor="ctr"/>
           <a:lstStyle/>
           <a:p>
-            <a:pPr indent="0" marL="0">
+            <a:pPr marL="0" indent="0">
               <a:buNone/>
             </a:pPr>
             <a:endParaRPr lang="en-US" dirty="0"/>
@@ -1467,7 +1145,7 @@
           <a:bodyPr wrap="square" lIns="0" tIns="0" rIns="0" bIns="0" rtlCol="0" anchor="t"/>
           <a:lstStyle/>
           <a:p>
-            <a:pPr algn="l" indent="0" marL="0">
+            <a:pPr marL="0" indent="0" algn="l">
               <a:spcAft>
                 <a:spcPts val="600"/>
               </a:spcAft>
@@ -1509,7 +1187,7 @@
           <a:bodyPr wrap="square" lIns="0" tIns="0" rIns="0" bIns="0" rtlCol="0" anchor="t"/>
           <a:lstStyle/>
           <a:p>
-            <a:pPr algn="l" indent="0" marL="0">
+            <a:pPr marL="0" indent="0" algn="l">
               <a:lnSpc>
                 <a:spcPts val="1540"/>
               </a:lnSpc>
@@ -1559,7 +1237,7 @@
           <a:bodyPr wrap="square" rtlCol="0" anchor="ctr"/>
           <a:lstStyle/>
           <a:p>
-            <a:pPr indent="0" marL="0">
+            <a:pPr marL="0" indent="0">
               <a:buNone/>
             </a:pPr>
             <a:endParaRPr lang="en-US" dirty="0"/>
@@ -1587,7 +1265,7 @@
           <a:bodyPr wrap="square" lIns="0" tIns="0" rIns="0" bIns="0" rtlCol="0" anchor="t"/>
           <a:lstStyle/>
           <a:p>
-            <a:pPr algn="l" indent="0" marL="0">
+            <a:pPr marL="0" indent="0" algn="l">
               <a:spcAft>
                 <a:spcPts val="600"/>
               </a:spcAft>
@@ -1629,7 +1307,7 @@
           <a:bodyPr wrap="square" lIns="0" tIns="0" rIns="0" bIns="0" rtlCol="0" anchor="t"/>
           <a:lstStyle/>
           <a:p>
-            <a:pPr algn="l" indent="0" marL="0">
+            <a:pPr marL="0" indent="0" algn="l">
               <a:lnSpc>
                 <a:spcPts val="1540"/>
               </a:lnSpc>
@@ -1672,6 +1350,13 @@
             <a:prstDash val="solid"/>
           </a:ln>
         </p:spPr>
+        <p:txBody>
+          <a:bodyPr/>
+          <a:lstStyle/>
+          <a:p>
+            <a:endParaRPr lang="en-GB"/>
+          </a:p>
+        </p:txBody>
       </p:sp>
       <p:sp>
         <p:nvSpPr>
@@ -1694,7 +1379,7 @@
           <a:bodyPr wrap="square" lIns="0" tIns="0" rIns="0" bIns="0" rtlCol="0" anchor="t"/>
           <a:lstStyle/>
           <a:p>
-            <a:pPr algn="l" indent="0" marL="0">
+            <a:pPr marL="0" indent="0" algn="l">
               <a:buNone/>
             </a:pPr>
             <a:r>
@@ -1733,7 +1418,7 @@
           <a:bodyPr wrap="square" lIns="0" tIns="0" rIns="0" bIns="0" rtlCol="0" anchor="t"/>
           <a:lstStyle/>
           <a:p>
-            <a:pPr algn="l" indent="0" marL="0">
+            <a:pPr marL="0" indent="0" algn="l">
               <a:buNone/>
             </a:pPr>
             <a:r>
@@ -1767,6 +1452,7 @@
         <a:solidFill>
           <a:srgbClr val="0F172A"/>
         </a:solidFill>
+        <a:effectLst/>
       </p:bgPr>
     </p:bg>
     <p:spTree>
@@ -1804,7 +1490,7 @@
           <a:bodyPr wrap="square" lIns="0" tIns="0" rIns="0" bIns="0" rtlCol="0" anchor="t"/>
           <a:lstStyle/>
           <a:p>
-            <a:pPr algn="l" indent="0" marL="0">
+            <a:pPr marL="0" indent="0" algn="l">
               <a:buNone/>
             </a:pPr>
             <a:r>
@@ -1843,7 +1529,7 @@
           <a:bodyPr wrap="square" lIns="0" tIns="0" rIns="0" bIns="0" rtlCol="0" anchor="t"/>
           <a:lstStyle/>
           <a:p>
-            <a:pPr algn="l" indent="0" marL="0">
+            <a:pPr marL="0" indent="0" algn="l">
               <a:spcBef>
                 <a:spcPts val="600"/>
               </a:spcBef>
@@ -1888,7 +1574,7 @@
           <a:bodyPr wrap="square" lIns="0" tIns="0" rIns="0" bIns="0" rtlCol="0" anchor="t"/>
           <a:lstStyle/>
           <a:p>
-            <a:pPr algn="l" indent="0" marL="0">
+            <a:pPr marL="0" indent="0" algn="l">
               <a:buNone/>
             </a:pPr>
             <a:r>
@@ -1908,223 +1594,7 @@
       </p:sp>
       <p:pic>
         <p:nvPicPr>
-          <p:cNvPr id="5" name="Image 0" descr="/tmp/claude-1000/-home-nodozi-projects-NEBIUS-MAR-2026-Nebius-serverless-llm-experiments-lab/c5359c07-1207-4b10-b30c-fa9e048bfd83/scratchpad/pptx/icons/solution.png">    </p:cNvPr>
-          <p:cNvPicPr>
-            <a:picLocks noChangeAspect="1"/>
-          </p:cNvPicPr>
-          <p:nvPr/>
-        </p:nvPicPr>
-        <p:blipFill>
-          <a:blip r:embed="rId1"/>
-          <a:stretch>
-            <a:fillRect/>
-          </a:stretch>
-        </p:blipFill>
-        <p:spPr>
-          <a:xfrm>
-            <a:off x="507950" y="1498402"/>
-            <a:ext cx="253901" cy="253901"/>
-          </a:xfrm>
-          <a:prstGeom prst="rect">
-            <a:avLst/>
-          </a:prstGeom>
-        </p:spPr>
-      </p:pic>
-      <p:sp>
-        <p:nvSpPr>
-          <p:cNvPr id="6" name="Text 3"/>
-          <p:cNvSpPr/>
-          <p:nvPr/>
-        </p:nvSpPr>
-        <p:spPr>
-          <a:xfrm>
-            <a:off x="888802" y="1473101"/>
-            <a:ext cx="4339489" cy="190500"/>
-          </a:xfrm>
-          <a:prstGeom prst="rect">
-            <a:avLst/>
-          </a:prstGeom>
-          <a:noFill/>
-          <a:ln/>
-        </p:spPr>
-        <p:txBody>
-          <a:bodyPr wrap="square" lIns="0" tIns="0" rIns="0" bIns="0" rtlCol="0" anchor="t"/>
-          <a:lstStyle/>
-          <a:p>
-            <a:pPr algn="l" indent="0" marL="0">
-              <a:spcAft>
-                <a:spcPts val="200"/>
-              </a:spcAft>
-              <a:buNone/>
-            </a:pPr>
-            <a:r>
-              <a:rPr lang="en-US" sz="1250" b="1" dirty="0">
-                <a:solidFill>
-                  <a:srgbClr val="FFFFFF"/>
-                </a:solidFill>
-                <a:latin typeface="Arial" pitchFamily="34" charset="0"/>
-                <a:ea typeface="Arial" pitchFamily="34" charset="-122"/>
-                <a:cs typeface="Arial" pitchFamily="34" charset="-120"/>
-              </a:rPr>
-              <a:t>No code, just presets</a:t>
-            </a:r>
-            <a:endParaRPr lang="en-US" sz="1250" dirty="0"/>
-          </a:p>
-        </p:txBody>
-      </p:sp>
-      <p:sp>
-        <p:nvSpPr>
-          <p:cNvPr id="7" name="Text 4"/>
-          <p:cNvSpPr/>
-          <p:nvPr/>
-        </p:nvSpPr>
-        <p:spPr>
-          <a:xfrm>
-            <a:off x="888802" y="1688902"/>
-            <a:ext cx="4339489" cy="346472"/>
-          </a:xfrm>
-          <a:prstGeom prst="rect">
-            <a:avLst/>
-          </a:prstGeom>
-          <a:noFill/>
-          <a:ln/>
-        </p:spPr>
-        <p:txBody>
-          <a:bodyPr wrap="square" lIns="0" tIns="0" rIns="0" bIns="0" rtlCol="0" anchor="t"/>
-          <a:lstStyle/>
-          <a:p>
-            <a:pPr algn="l" indent="0" marL="0">
-              <a:lnSpc>
-                <a:spcPts val="1365"/>
-              </a:lnSpc>
-              <a:buNone/>
-            </a:pPr>
-            <a:r>
-              <a:rPr lang="en-US" sz="1050" dirty="0">
-                <a:solidFill>
-                  <a:srgbClr val="CBD5E1"/>
-                </a:solidFill>
-                <a:latin typeface="Arial" pitchFamily="34" charset="0"/>
-                <a:ea typeface="Arial" pitchFamily="34" charset="-122"/>
-                <a:cs typeface="Arial" pitchFamily="34" charset="-120"/>
-              </a:rPr>
-              <a:t>Tiny Transformer, MoE, RNN, High-LR — pick one, tweak sliders, hit Start.</a:t>
-            </a:r>
-            <a:endParaRPr lang="en-US" sz="1050" dirty="0"/>
-          </a:p>
-        </p:txBody>
-      </p:sp>
-      <p:pic>
-        <p:nvPicPr>
-          <p:cNvPr id="8" name="Image 1" descr="/tmp/claude-1000/-home-nodozi-projects-NEBIUS-MAR-2026-Nebius-serverless-llm-experiments-lab/c5359c07-1207-4b10-b30c-fa9e048bfd83/scratchpad/pptx/icons/pause.png">    </p:cNvPr>
-          <p:cNvPicPr>
-            <a:picLocks noChangeAspect="1"/>
-          </p:cNvPicPr>
-          <p:nvPr/>
-        </p:nvPicPr>
-        <p:blipFill>
-          <a:blip r:embed="rId2"/>
-          <a:stretch>
-            <a:fillRect/>
-          </a:stretch>
-        </p:blipFill>
-        <p:spPr>
-          <a:xfrm>
-            <a:off x="507950" y="2213074"/>
-            <a:ext cx="253901" cy="253901"/>
-          </a:xfrm>
-          <a:prstGeom prst="rect">
-            <a:avLst/>
-          </a:prstGeom>
-        </p:spPr>
-      </p:pic>
-      <p:sp>
-        <p:nvSpPr>
-          <p:cNvPr id="9" name="Text 5"/>
-          <p:cNvSpPr/>
-          <p:nvPr/>
-        </p:nvSpPr>
-        <p:spPr>
-          <a:xfrm>
-            <a:off x="888802" y="2187773"/>
-            <a:ext cx="4339489" cy="190500"/>
-          </a:xfrm>
-          <a:prstGeom prst="rect">
-            <a:avLst/>
-          </a:prstGeom>
-          <a:noFill/>
-          <a:ln/>
-        </p:spPr>
-        <p:txBody>
-          <a:bodyPr wrap="square" lIns="0" tIns="0" rIns="0" bIns="0" rtlCol="0" anchor="t"/>
-          <a:lstStyle/>
-          <a:p>
-            <a:pPr algn="l" indent="0" marL="0">
-              <a:spcAft>
-                <a:spcPts val="200"/>
-              </a:spcAft>
-              <a:buNone/>
-            </a:pPr>
-            <a:r>
-              <a:rPr lang="en-US" sz="1250" b="1" dirty="0">
-                <a:solidFill>
-                  <a:srgbClr val="FFFFFF"/>
-                </a:solidFill>
-                <a:latin typeface="Arial" pitchFamily="34" charset="0"/>
-                <a:ea typeface="Arial" pitchFamily="34" charset="-122"/>
-                <a:cs typeface="Arial" pitchFamily="34" charset="-120"/>
-              </a:rPr>
-              <a:t>Pause it and ask what it knows</a:t>
-            </a:r>
-            <a:endParaRPr lang="en-US" sz="1250" dirty="0"/>
-          </a:p>
-        </p:txBody>
-      </p:sp>
-      <p:sp>
-        <p:nvSpPr>
-          <p:cNvPr id="10" name="Text 6"/>
-          <p:cNvSpPr/>
-          <p:nvPr/>
-        </p:nvSpPr>
-        <p:spPr>
-          <a:xfrm>
-            <a:off x="888802" y="2403574"/>
-            <a:ext cx="4339489" cy="173236"/>
-          </a:xfrm>
-          <a:prstGeom prst="rect">
-            <a:avLst/>
-          </a:prstGeom>
-          <a:noFill/>
-          <a:ln/>
-        </p:spPr>
-        <p:txBody>
-          <a:bodyPr wrap="square" lIns="0" tIns="0" rIns="0" bIns="0" rtlCol="0" anchor="t"/>
-          <a:lstStyle/>
-          <a:p>
-            <a:pPr algn="l" indent="0" marL="0">
-              <a:lnSpc>
-                <a:spcPts val="1365"/>
-              </a:lnSpc>
-              <a:buNone/>
-            </a:pPr>
-            <a:r>
-              <a:rPr lang="en-US" sz="1050" dirty="0">
-                <a:solidFill>
-                  <a:srgbClr val="CBD5E1"/>
-                </a:solidFill>
-                <a:latin typeface="Arial" pitchFamily="34" charset="0"/>
-                <a:ea typeface="Arial" pitchFamily="34" charset="-122"/>
-                <a:cs typeface="Arial" pitchFamily="34" charset="-120"/>
-              </a:rPr>
-              <a:t>Prompt the partially-trained model mid-run. Resume. Ask again later.</a:t>
-            </a:r>
-            <a:endParaRPr lang="en-US" sz="1050" dirty="0"/>
-          </a:p>
-        </p:txBody>
-      </p:sp>
-      <p:pic>
-        <p:nvPicPr>
-          <p:cNvPr id="11" name="Image 2" descr="/tmp/claude-1000/-home-nodozi-projects-NEBIUS-MAR-2026-Nebius-serverless-llm-experiments-lab/c5359c07-1207-4b10-b30c-fa9e048bfd83/scratchpad/pptx/icons/inspect.png">    </p:cNvPr>
+          <p:cNvPr id="5" name="Image 0" descr="/tmp/claude-1000/-home-nodozi-projects-NEBIUS-MAR-2026-Nebius-serverless-llm-experiments-lab/c5359c07-1207-4b10-b30c-fa9e048bfd83/scratchpad/pptx/icons/solution.png"/>
           <p:cNvPicPr>
             <a:picLocks noChangeAspect="1"/>
           </p:cNvPicPr>
@@ -2138,7 +1608,7 @@
         </p:blipFill>
         <p:spPr>
           <a:xfrm>
-            <a:off x="507950" y="2754511"/>
+            <a:off x="507950" y="1498402"/>
             <a:ext cx="253901" cy="253901"/>
           </a:xfrm>
           <a:prstGeom prst="rect">
@@ -2148,13 +1618,13 @@
       </p:pic>
       <p:sp>
         <p:nvSpPr>
-          <p:cNvPr id="12" name="Text 7"/>
-          <p:cNvSpPr/>
-          <p:nvPr/>
-        </p:nvSpPr>
-        <p:spPr>
-          <a:xfrm>
-            <a:off x="888802" y="2729210"/>
+          <p:cNvPr id="6" name="Text 3"/>
+          <p:cNvSpPr/>
+          <p:nvPr/>
+        </p:nvSpPr>
+        <p:spPr>
+          <a:xfrm>
+            <a:off x="888802" y="1473101"/>
             <a:ext cx="4339489" cy="190500"/>
           </a:xfrm>
           <a:prstGeom prst="rect">
@@ -2167,7 +1637,7 @@
           <a:bodyPr wrap="square" lIns="0" tIns="0" rIns="0" bIns="0" rtlCol="0" anchor="t"/>
           <a:lstStyle/>
           <a:p>
-            <a:pPr algn="l" indent="0" marL="0">
+            <a:pPr marL="0" indent="0" algn="l">
               <a:spcAft>
                 <a:spcPts val="200"/>
               </a:spcAft>
@@ -2182,7 +1652,7 @@
                 <a:ea typeface="Arial" pitchFamily="34" charset="-122"/>
                 <a:cs typeface="Arial" pitchFamily="34" charset="-120"/>
               </a:rPr>
-              <a:t>Actually look inside</a:t>
+              <a:t>No code, just presets</a:t>
             </a:r>
             <a:endParaRPr lang="en-US" sz="1250" dirty="0"/>
           </a:p>
@@ -2190,26 +1660,26 @@
       </p:sp>
       <p:sp>
         <p:nvSpPr>
-          <p:cNvPr id="13" name="Text 8"/>
-          <p:cNvSpPr/>
-          <p:nvPr/>
-        </p:nvSpPr>
-        <p:spPr>
-          <a:xfrm>
-            <a:off x="888802" y="2945011"/>
-            <a:ext cx="4339489" cy="173236"/>
-          </a:xfrm>
-          <a:prstGeom prst="rect">
-            <a:avLst/>
-          </a:prstGeom>
-          <a:noFill/>
-          <a:ln/>
-        </p:spPr>
-        <p:txBody>
-          <a:bodyPr wrap="square" lIns="0" tIns="0" rIns="0" bIns="0" rtlCol="0" anchor="t"/>
-          <a:lstStyle/>
-          <a:p>
-            <a:pPr algn="l" indent="0" marL="0">
+          <p:cNvPr id="7" name="Text 4"/>
+          <p:cNvSpPr/>
+          <p:nvPr/>
+        </p:nvSpPr>
+        <p:spPr>
+          <a:xfrm>
+            <a:off x="888802" y="1688902"/>
+            <a:ext cx="4339489" cy="346472"/>
+          </a:xfrm>
+          <a:prstGeom prst="rect">
+            <a:avLst/>
+          </a:prstGeom>
+          <a:noFill/>
+          <a:ln/>
+        </p:spPr>
+        <p:txBody>
+          <a:bodyPr wrap="square" lIns="0" tIns="0" rIns="0" bIns="0" rtlCol="0" anchor="t"/>
+          <a:lstStyle/>
+          <a:p>
+            <a:pPr marL="0" indent="0" algn="l">
               <a:lnSpc>
                 <a:spcPts val="1365"/>
               </a:lnSpc>
@@ -2224,7 +1694,7 @@
                 <a:ea typeface="Arial" pitchFamily="34" charset="-122"/>
                 <a:cs typeface="Arial" pitchFamily="34" charset="-120"/>
               </a:rPr>
-              <a:t>Attention maps, Q/K/V, top-k logits — a real Inspector, not a black box.</a:t>
+              <a:t>Tiny Transformer, MoE, RNN, High-LR — pick one, tweak sliders, hit Start.</a:t>
             </a:r>
             <a:endParaRPr lang="en-US" sz="1050" dirty="0"/>
           </a:p>
@@ -2232,7 +1702,7 @@
       </p:sp>
       <p:pic>
         <p:nvPicPr>
-          <p:cNvPr id="14" name="Image 3" descr="/tmp/claude-1000/-home-nodozi-projects-NEBIUS-MAR-2026-Nebius-serverless-llm-experiments-lab/c5359c07-1207-4b10-b30c-fa9e048bfd83/scratchpad/pptx/icons/chatbot.png">    </p:cNvPr>
+          <p:cNvPr id="8" name="Image 1" descr="/tmp/claude-1000/-home-nodozi-projects-NEBIUS-MAR-2026-Nebius-serverless-llm-experiments-lab/c5359c07-1207-4b10-b30c-fa9e048bfd83/scratchpad/pptx/icons/pause.png"/>
           <p:cNvPicPr>
             <a:picLocks noChangeAspect="1"/>
           </p:cNvPicPr>
@@ -2246,7 +1716,7 @@
         </p:blipFill>
         <p:spPr>
           <a:xfrm>
-            <a:off x="507950" y="3295948"/>
+            <a:off x="507950" y="2213074"/>
             <a:ext cx="253901" cy="253901"/>
           </a:xfrm>
           <a:prstGeom prst="rect">
@@ -2256,13 +1726,13 @@
       </p:pic>
       <p:sp>
         <p:nvSpPr>
-          <p:cNvPr id="15" name="Text 9"/>
-          <p:cNvSpPr/>
-          <p:nvPr/>
-        </p:nvSpPr>
-        <p:spPr>
-          <a:xfrm>
-            <a:off x="888802" y="3270647"/>
+          <p:cNvPr id="9" name="Text 5"/>
+          <p:cNvSpPr/>
+          <p:nvPr/>
+        </p:nvSpPr>
+        <p:spPr>
+          <a:xfrm>
+            <a:off x="888802" y="2187773"/>
             <a:ext cx="4339489" cy="190500"/>
           </a:xfrm>
           <a:prstGeom prst="rect">
@@ -2275,7 +1745,7 @@
           <a:bodyPr wrap="square" lIns="0" tIns="0" rIns="0" bIns="0" rtlCol="0" anchor="t"/>
           <a:lstStyle/>
           <a:p>
-            <a:pPr algn="l" indent="0" marL="0">
+            <a:pPr marL="0" indent="0" algn="l">
               <a:spcAft>
                 <a:spcPts val="200"/>
               </a:spcAft>
@@ -2290,7 +1760,7 @@
                 <a:ea typeface="Arial" pitchFamily="34" charset="-122"/>
                 <a:cs typeface="Arial" pitchFamily="34" charset="-120"/>
               </a:rPr>
-              <a:t>A chatbot that's read your run</a:t>
+              <a:t>Pause it and ask what it knows</a:t>
             </a:r>
             <a:endParaRPr lang="en-US" sz="1250" dirty="0"/>
           </a:p>
@@ -2298,13 +1768,13 @@
       </p:sp>
       <p:sp>
         <p:nvSpPr>
-          <p:cNvPr id="16" name="Text 10"/>
-          <p:cNvSpPr/>
-          <p:nvPr/>
-        </p:nvSpPr>
-        <p:spPr>
-          <a:xfrm>
-            <a:off x="888802" y="3486448"/>
+          <p:cNvPr id="10" name="Text 6"/>
+          <p:cNvSpPr/>
+          <p:nvPr/>
+        </p:nvSpPr>
+        <p:spPr>
+          <a:xfrm>
+            <a:off x="888802" y="2403574"/>
             <a:ext cx="4339489" cy="173236"/>
           </a:xfrm>
           <a:prstGeom prst="rect">
@@ -2317,7 +1787,7 @@
           <a:bodyPr wrap="square" lIns="0" tIns="0" rIns="0" bIns="0" rtlCol="0" anchor="t"/>
           <a:lstStyle/>
           <a:p>
-            <a:pPr algn="l" indent="0" marL="0">
+            <a:pPr marL="0" indent="0" algn="l">
               <a:lnSpc>
                 <a:spcPts val="1365"/>
               </a:lnSpc>
@@ -2332,7 +1802,7 @@
                 <a:ea typeface="Arial" pitchFamily="34" charset="-122"/>
                 <a:cs typeface="Arial" pitchFamily="34" charset="-120"/>
               </a:rPr>
-              <a:t>Grounded in your config, metrics and logs — not a generic explainer.</a:t>
+              <a:t>Prompt the partially-trained model mid-run. Resume. Ask again later.</a:t>
             </a:r>
             <a:endParaRPr lang="en-US" sz="1050" dirty="0"/>
           </a:p>
@@ -2340,7 +1810,7 @@
       </p:sp>
       <p:pic>
         <p:nvPicPr>
-          <p:cNvPr id="17" name="Image 4" descr="/tmp/claude-1000/-home-nodozi-projects-NEBIUS-MAR-2026-Nebius-serverless-llm-experiments-lab/c5359c07-1207-4b10-b30c-fa9e048bfd83/scratchpad/pptx/dashboard.png">    </p:cNvPr>
+          <p:cNvPr id="11" name="Image 2" descr="/tmp/claude-1000/-home-nodozi-projects-NEBIUS-MAR-2026-Nebius-serverless-llm-experiments-lab/c5359c07-1207-4b10-b30c-fa9e048bfd83/scratchpad/pptx/icons/inspect.png"/>
           <p:cNvPicPr>
             <a:picLocks noChangeAspect="1"/>
           </p:cNvPicPr>
@@ -2354,8 +1824,8 @@
         </p:blipFill>
         <p:spPr>
           <a:xfrm>
-            <a:off x="5143202" y="431750"/>
-            <a:ext cx="3810000" cy="2146846"/>
+            <a:off x="507950" y="2754511"/>
+            <a:ext cx="253901" cy="253901"/>
           </a:xfrm>
           <a:prstGeom prst="rect">
             <a:avLst/>
@@ -2364,40 +1834,193 @@
       </p:pic>
       <p:sp>
         <p:nvSpPr>
-          <p:cNvPr id="18" name="Text 11"/>
-          <p:cNvSpPr/>
-          <p:nvPr/>
-        </p:nvSpPr>
-        <p:spPr>
-          <a:xfrm>
-            <a:off x="5575241" y="2680097"/>
-            <a:ext cx="2945922" cy="133350"/>
-          </a:xfrm>
-          <a:prstGeom prst="rect">
-            <a:avLst/>
-          </a:prstGeom>
-          <a:noFill/>
-          <a:ln/>
-        </p:spPr>
-        <p:txBody>
-          <a:bodyPr wrap="square" lIns="0" tIns="0" rIns="0" bIns="0" rtlCol="0" anchor="t"/>
-          <a:lstStyle/>
-          <a:p>
-            <a:pPr algn="ctr" indent="0" marL="0">
-              <a:buNone/>
-            </a:pPr>
-            <a:r>
-              <a:rPr lang="en-US" sz="950" dirty="0">
-                <a:solidFill>
-                  <a:srgbClr val="64748B"/>
-                </a:solidFill>
-                <a:latin typeface="Arial" pitchFamily="34" charset="0"/>
-                <a:ea typeface="Arial" pitchFamily="34" charset="-122"/>
-                <a:cs typeface="Arial" pitchFamily="34" charset="-120"/>
-              </a:rPr>
-              <a:t>The actual dashboard. Loss chart, config, live training.</a:t>
-            </a:r>
-            <a:endParaRPr lang="en-US" sz="950" dirty="0"/>
+          <p:cNvPr id="12" name="Text 7"/>
+          <p:cNvSpPr/>
+          <p:nvPr/>
+        </p:nvSpPr>
+        <p:spPr>
+          <a:xfrm>
+            <a:off x="888802" y="2729210"/>
+            <a:ext cx="4339489" cy="190500"/>
+          </a:xfrm>
+          <a:prstGeom prst="rect">
+            <a:avLst/>
+          </a:prstGeom>
+          <a:noFill/>
+          <a:ln/>
+        </p:spPr>
+        <p:txBody>
+          <a:bodyPr wrap="square" lIns="0" tIns="0" rIns="0" bIns="0" rtlCol="0" anchor="t"/>
+          <a:lstStyle/>
+          <a:p>
+            <a:pPr marL="0" indent="0" algn="l">
+              <a:spcAft>
+                <a:spcPts val="200"/>
+              </a:spcAft>
+              <a:buNone/>
+            </a:pPr>
+            <a:r>
+              <a:rPr lang="en-US" sz="1250" b="1" dirty="0">
+                <a:solidFill>
+                  <a:srgbClr val="FFFFFF"/>
+                </a:solidFill>
+                <a:latin typeface="Arial" pitchFamily="34" charset="0"/>
+                <a:ea typeface="Arial" pitchFamily="34" charset="-122"/>
+                <a:cs typeface="Arial" pitchFamily="34" charset="-120"/>
+              </a:rPr>
+              <a:t>Actually look inside</a:t>
+            </a:r>
+            <a:endParaRPr lang="en-US" sz="1250" dirty="0"/>
+          </a:p>
+        </p:txBody>
+      </p:sp>
+      <p:sp>
+        <p:nvSpPr>
+          <p:cNvPr id="13" name="Text 8"/>
+          <p:cNvSpPr/>
+          <p:nvPr/>
+        </p:nvSpPr>
+        <p:spPr>
+          <a:xfrm>
+            <a:off x="888802" y="2945011"/>
+            <a:ext cx="4339489" cy="173236"/>
+          </a:xfrm>
+          <a:prstGeom prst="rect">
+            <a:avLst/>
+          </a:prstGeom>
+          <a:noFill/>
+          <a:ln/>
+        </p:spPr>
+        <p:txBody>
+          <a:bodyPr wrap="square" lIns="0" tIns="0" rIns="0" bIns="0" rtlCol="0" anchor="t"/>
+          <a:lstStyle/>
+          <a:p>
+            <a:pPr marL="0" indent="0" algn="l">
+              <a:lnSpc>
+                <a:spcPts val="1365"/>
+              </a:lnSpc>
+              <a:buNone/>
+            </a:pPr>
+            <a:r>
+              <a:rPr lang="en-US" sz="1050" dirty="0">
+                <a:solidFill>
+                  <a:srgbClr val="CBD5E1"/>
+                </a:solidFill>
+                <a:latin typeface="Arial" pitchFamily="34" charset="0"/>
+                <a:ea typeface="Arial" pitchFamily="34" charset="-122"/>
+                <a:cs typeface="Arial" pitchFamily="34" charset="-120"/>
+              </a:rPr>
+              <a:t>Attention maps, Q/K/V, top-k logits — a real Inspector, not a black box.</a:t>
+            </a:r>
+            <a:endParaRPr lang="en-US" sz="1050" dirty="0"/>
+          </a:p>
+        </p:txBody>
+      </p:sp>
+      <p:pic>
+        <p:nvPicPr>
+          <p:cNvPr id="14" name="Image 3" descr="/tmp/claude-1000/-home-nodozi-projects-NEBIUS-MAR-2026-Nebius-serverless-llm-experiments-lab/c5359c07-1207-4b10-b30c-fa9e048bfd83/scratchpad/pptx/icons/chatbot.png"/>
+          <p:cNvPicPr>
+            <a:picLocks noChangeAspect="1"/>
+          </p:cNvPicPr>
+          <p:nvPr/>
+        </p:nvPicPr>
+        <p:blipFill>
+          <a:blip r:embed="rId6"/>
+          <a:stretch>
+            <a:fillRect/>
+          </a:stretch>
+        </p:blipFill>
+        <p:spPr>
+          <a:xfrm>
+            <a:off x="507950" y="3295948"/>
+            <a:ext cx="253901" cy="253901"/>
+          </a:xfrm>
+          <a:prstGeom prst="rect">
+            <a:avLst/>
+          </a:prstGeom>
+        </p:spPr>
+      </p:pic>
+      <p:sp>
+        <p:nvSpPr>
+          <p:cNvPr id="15" name="Text 9"/>
+          <p:cNvSpPr/>
+          <p:nvPr/>
+        </p:nvSpPr>
+        <p:spPr>
+          <a:xfrm>
+            <a:off x="888802" y="3270647"/>
+            <a:ext cx="4339489" cy="190500"/>
+          </a:xfrm>
+          <a:prstGeom prst="rect">
+            <a:avLst/>
+          </a:prstGeom>
+          <a:noFill/>
+          <a:ln/>
+        </p:spPr>
+        <p:txBody>
+          <a:bodyPr wrap="square" lIns="0" tIns="0" rIns="0" bIns="0" rtlCol="0" anchor="t"/>
+          <a:lstStyle/>
+          <a:p>
+            <a:pPr marL="0" indent="0" algn="l">
+              <a:spcAft>
+                <a:spcPts val="200"/>
+              </a:spcAft>
+              <a:buNone/>
+            </a:pPr>
+            <a:r>
+              <a:rPr lang="en-US" sz="1250" b="1" dirty="0">
+                <a:solidFill>
+                  <a:srgbClr val="FFFFFF"/>
+                </a:solidFill>
+                <a:latin typeface="Arial" pitchFamily="34" charset="0"/>
+                <a:ea typeface="Arial" pitchFamily="34" charset="-122"/>
+                <a:cs typeface="Arial" pitchFamily="34" charset="-120"/>
+              </a:rPr>
+              <a:t>A chatbot that's read your run</a:t>
+            </a:r>
+            <a:endParaRPr lang="en-US" sz="1250" dirty="0"/>
+          </a:p>
+        </p:txBody>
+      </p:sp>
+      <p:sp>
+        <p:nvSpPr>
+          <p:cNvPr id="16" name="Text 10"/>
+          <p:cNvSpPr/>
+          <p:nvPr/>
+        </p:nvSpPr>
+        <p:spPr>
+          <a:xfrm>
+            <a:off x="888802" y="3486448"/>
+            <a:ext cx="4339489" cy="173236"/>
+          </a:xfrm>
+          <a:prstGeom prst="rect">
+            <a:avLst/>
+          </a:prstGeom>
+          <a:noFill/>
+          <a:ln/>
+        </p:spPr>
+        <p:txBody>
+          <a:bodyPr wrap="square" lIns="0" tIns="0" rIns="0" bIns="0" rtlCol="0" anchor="t"/>
+          <a:lstStyle/>
+          <a:p>
+            <a:pPr marL="0" indent="0" algn="l">
+              <a:lnSpc>
+                <a:spcPts val="1365"/>
+              </a:lnSpc>
+              <a:buNone/>
+            </a:pPr>
+            <a:r>
+              <a:rPr lang="en-US" sz="1050" dirty="0">
+                <a:solidFill>
+                  <a:srgbClr val="CBD5E1"/>
+                </a:solidFill>
+                <a:latin typeface="Arial" pitchFamily="34" charset="0"/>
+                <a:ea typeface="Arial" pitchFamily="34" charset="-122"/>
+                <a:cs typeface="Arial" pitchFamily="34" charset="-120"/>
+              </a:rPr>
+              <a:t>Grounded in your config, metrics and logs — not a generic explainer.</a:t>
+            </a:r>
+            <a:endParaRPr lang="en-US" sz="1050" dirty="0"/>
           </a:p>
         </p:txBody>
       </p:sp>
@@ -2417,6 +2040,7 @@
         <a:solidFill>
           <a:srgbClr val="0F172A"/>
         </a:solidFill>
+        <a:effectLst/>
       </p:bgPr>
     </p:bg>
     <p:spTree>
@@ -2454,7 +2078,7 @@
           <a:bodyPr wrap="square" lIns="0" tIns="0" rIns="0" bIns="0" rtlCol="0" anchor="t"/>
           <a:lstStyle/>
           <a:p>
-            <a:pPr algn="l" indent="0" marL="0">
+            <a:pPr marL="0" indent="0" algn="l">
               <a:buNone/>
             </a:pPr>
             <a:r>
@@ -2493,7 +2117,7 @@
           <a:bodyPr wrap="square" lIns="0" tIns="0" rIns="0" bIns="0" rtlCol="0" anchor="t"/>
           <a:lstStyle/>
           <a:p>
-            <a:pPr algn="l" indent="0" marL="0">
+            <a:pPr marL="0" indent="0" algn="l">
               <a:spcBef>
                 <a:spcPts val="200"/>
               </a:spcBef>
@@ -2543,7 +2167,7 @@
           <a:bodyPr wrap="square" rtlCol="0" anchor="ctr"/>
           <a:lstStyle/>
           <a:p>
-            <a:pPr indent="0" marL="0">
+            <a:pPr marL="0" indent="0">
               <a:buNone/>
             </a:pPr>
             <a:endParaRPr lang="en-US" dirty="0"/>
@@ -2575,7 +2199,7 @@
           <a:bodyPr wrap="square" rtlCol="0" anchor="ctr"/>
           <a:lstStyle/>
           <a:p>
-            <a:pPr indent="0" marL="0">
+            <a:pPr marL="0" indent="0">
               <a:buNone/>
             </a:pPr>
             <a:endParaRPr lang="en-US" dirty="0"/>
@@ -2603,7 +2227,7 @@
           <a:bodyPr wrap="square" lIns="0" tIns="0" rIns="0" bIns="0" rtlCol="0" anchor="t"/>
           <a:lstStyle/>
           <a:p>
-            <a:pPr algn="l" indent="0" marL="0">
+            <a:pPr marL="0" indent="0" algn="l">
               <a:buNone/>
             </a:pPr>
             <a:r>
@@ -2642,7 +2266,7 @@
           <a:bodyPr wrap="square" lIns="0" tIns="0" rIns="0" bIns="0" rtlCol="0" anchor="t"/>
           <a:lstStyle/>
           <a:p>
-            <a:pPr algn="l" indent="0" marL="0">
+            <a:pPr marL="0" indent="0" algn="l">
               <a:buNone/>
             </a:pPr>
             <a:r>
@@ -2689,7 +2313,7 @@
           <a:bodyPr wrap="square" rtlCol="0" anchor="ctr"/>
           <a:lstStyle/>
           <a:p>
-            <a:pPr indent="0" marL="0">
+            <a:pPr marL="0" indent="0">
               <a:buNone/>
             </a:pPr>
             <a:endParaRPr lang="en-US" dirty="0"/>
@@ -2721,7 +2345,7 @@
           <a:bodyPr wrap="square" rtlCol="0" anchor="ctr"/>
           <a:lstStyle/>
           <a:p>
-            <a:pPr indent="0" marL="0">
+            <a:pPr marL="0" indent="0">
               <a:buNone/>
             </a:pPr>
             <a:endParaRPr lang="en-US" dirty="0"/>
@@ -2749,7 +2373,7 @@
           <a:bodyPr wrap="square" lIns="0" tIns="0" rIns="0" bIns="0" rtlCol="0" anchor="t"/>
           <a:lstStyle/>
           <a:p>
-            <a:pPr algn="l" indent="0" marL="0">
+            <a:pPr marL="0" indent="0" algn="l">
               <a:buNone/>
             </a:pPr>
             <a:r>
@@ -2788,7 +2412,7 @@
           <a:bodyPr wrap="square" lIns="0" tIns="0" rIns="0" bIns="0" rtlCol="0" anchor="t"/>
           <a:lstStyle/>
           <a:p>
-            <a:pPr algn="l" indent="0" marL="0">
+            <a:pPr marL="0" indent="0" algn="l">
               <a:buNone/>
             </a:pPr>
             <a:r>
@@ -2835,7 +2459,7 @@
           <a:bodyPr wrap="square" rtlCol="0" anchor="ctr"/>
           <a:lstStyle/>
           <a:p>
-            <a:pPr indent="0" marL="0">
+            <a:pPr marL="0" indent="0">
               <a:buNone/>
             </a:pPr>
             <a:endParaRPr lang="en-US" dirty="0"/>
@@ -2867,7 +2491,7 @@
           <a:bodyPr wrap="square" rtlCol="0" anchor="ctr"/>
           <a:lstStyle/>
           <a:p>
-            <a:pPr indent="0" marL="0">
+            <a:pPr marL="0" indent="0">
               <a:buNone/>
             </a:pPr>
             <a:endParaRPr lang="en-US" dirty="0"/>
@@ -2895,7 +2519,7 @@
           <a:bodyPr wrap="square" lIns="0" tIns="0" rIns="0" bIns="0" rtlCol="0" anchor="t"/>
           <a:lstStyle/>
           <a:p>
-            <a:pPr algn="l" indent="0" marL="0">
+            <a:pPr marL="0" indent="0" algn="l">
               <a:buNone/>
             </a:pPr>
             <a:r>
@@ -2934,7 +2558,7 @@
           <a:bodyPr wrap="square" lIns="0" tIns="0" rIns="0" bIns="0" rtlCol="0" anchor="t"/>
           <a:lstStyle/>
           <a:p>
-            <a:pPr algn="l" indent="0" marL="0">
+            <a:pPr marL="0" indent="0" algn="l">
               <a:buNone/>
             </a:pPr>
             <a:r>
@@ -2960,7 +2584,7 @@
         </p:nvSpPr>
         <p:spPr>
           <a:xfrm>
-            <a:off x="381000" y="1234529"/>
+            <a:off x="917944" y="1574772"/>
             <a:ext cx="4991100" cy="3122116"/>
           </a:xfrm>
           <a:prstGeom prst="roundRect">
@@ -2973,7 +2597,7 @@
           </a:solidFill>
           <a:ln/>
           <a:effectLst>
-            <a:outerShdw sx="100000" sy="100000" kx="0" ky="0" algn="bl" rotWithShape="0" blurRad="114300" dist="40411" dir="2700000">
+            <a:outerShdw blurRad="114300" dist="40411" dir="2700000" algn="bl" rotWithShape="0">
               <a:srgbClr val="000000">
                 <a:alpha val="35000"/>
               </a:srgbClr>
@@ -2984,7 +2608,7 @@
           <a:bodyPr wrap="square" rtlCol="0" anchor="ctr"/>
           <a:lstStyle/>
           <a:p>
-            <a:pPr indent="0" marL="0">
+            <a:pPr marL="0" indent="0">
               <a:buNone/>
             </a:pPr>
             <a:endParaRPr lang="en-US" dirty="0"/>
@@ -2993,21 +2617,21 @@
       </p:sp>
       <p:pic>
         <p:nvPicPr>
-          <p:cNvPr id="17" name="Image 0" descr="/tmp/claude-1000/-home-nodozi-projects-NEBIUS-MAR-2026-Nebius-serverless-llm-experiments-lab/c5359c07-1207-4b10-b30c-fa9e048bfd83/scratchpad/pptx/arch_diagram.png">    </p:cNvPr>
+          <p:cNvPr id="17" name="Image 0" descr="/tmp/claude-1000/-home-nodozi-projects-NEBIUS-MAR-2026-Nebius-serverless-llm-experiments-lab/c5359c07-1207-4b10-b30c-fa9e048bfd83/scratchpad/pptx/arch_diagram.png"/>
           <p:cNvPicPr>
             <a:picLocks noChangeAspect="1"/>
           </p:cNvPicPr>
           <p:nvPr/>
         </p:nvPicPr>
         <p:blipFill>
-          <a:blip r:embed="rId1"/>
+          <a:blip r:embed="rId3"/>
           <a:stretch>
             <a:fillRect/>
           </a:stretch>
         </p:blipFill>
         <p:spPr>
           <a:xfrm>
-            <a:off x="457200" y="1310729"/>
+            <a:off x="994144" y="1650972"/>
             <a:ext cx="4838700" cy="2792016"/>
           </a:xfrm>
           <a:prstGeom prst="rect">
@@ -3023,7 +2647,7 @@
         </p:nvSpPr>
         <p:spPr>
           <a:xfrm>
-            <a:off x="1282906" y="4166146"/>
+            <a:off x="1819850" y="4506389"/>
             <a:ext cx="3187139" cy="114300"/>
           </a:xfrm>
           <a:prstGeom prst="rect">
@@ -3036,7 +2660,7 @@
           <a:bodyPr wrap="square" lIns="0" tIns="0" rIns="0" bIns="0" rtlCol="0" anchor="t"/>
           <a:lstStyle/>
           <a:p>
-            <a:pPr algn="ctr" indent="0" marL="0">
+            <a:pPr marL="0" indent="0" algn="ctr">
               <a:buNone/>
             </a:pPr>
             <a:r>
@@ -3062,7 +2686,7 @@
         </p:nvSpPr>
         <p:spPr>
           <a:xfrm>
-            <a:off x="5575250" y="1234529"/>
+            <a:off x="6112194" y="1574772"/>
             <a:ext cx="2041475" cy="3120330"/>
           </a:xfrm>
           <a:prstGeom prst="roundRect">
@@ -3075,7 +2699,7 @@
           </a:solidFill>
           <a:ln/>
           <a:effectLst>
-            <a:outerShdw sx="100000" sy="100000" kx="0" ky="0" algn="bl" rotWithShape="0" blurRad="114300" dist="40411" dir="2700000">
+            <a:outerShdw blurRad="114300" dist="40411" dir="2700000" algn="bl" rotWithShape="0">
               <a:srgbClr val="000000">
                 <a:alpha val="35000"/>
               </a:srgbClr>
@@ -3086,7 +2710,7 @@
           <a:bodyPr wrap="square" rtlCol="0" anchor="ctr"/>
           <a:lstStyle/>
           <a:p>
-            <a:pPr indent="0" marL="0">
+            <a:pPr marL="0" indent="0">
               <a:buNone/>
             </a:pPr>
             <a:endParaRPr lang="en-US" dirty="0"/>
@@ -3095,21 +2719,21 @@
       </p:sp>
       <p:pic>
         <p:nvPicPr>
-          <p:cNvPr id="20" name="Image 1" descr="/tmp/claude-1000/-home-nodozi-projects-NEBIUS-MAR-2026-Nebius-serverless-llm-experiments-lab/c5359c07-1207-4b10-b30c-fa9e048bfd83/scratchpad/pptx/lifecycle_diagram.png">    </p:cNvPr>
+          <p:cNvPr id="20" name="Image 1" descr="/tmp/claude-1000/-home-nodozi-projects-NEBIUS-MAR-2026-Nebius-serverless-llm-experiments-lab/c5359c07-1207-4b10-b30c-fa9e048bfd83/scratchpad/pptx/lifecycle_diagram.png"/>
           <p:cNvPicPr>
             <a:picLocks noChangeAspect="1"/>
           </p:cNvPicPr>
           <p:nvPr/>
         </p:nvPicPr>
         <p:blipFill>
-          <a:blip r:embed="rId2"/>
+          <a:blip r:embed="rId4"/>
           <a:stretch>
             <a:fillRect/>
           </a:stretch>
         </p:blipFill>
         <p:spPr>
           <a:xfrm>
-            <a:off x="5738664" y="1310729"/>
+            <a:off x="6290092" y="1714373"/>
             <a:ext cx="1714500" cy="2790230"/>
           </a:xfrm>
           <a:prstGeom prst="rect">
@@ -3125,7 +2749,7 @@
         </p:nvSpPr>
         <p:spPr>
           <a:xfrm>
-            <a:off x="5632560" y="4164360"/>
+            <a:off x="6169504" y="4504603"/>
             <a:ext cx="1926857" cy="114300"/>
           </a:xfrm>
           <a:prstGeom prst="rect">
@@ -3138,7 +2762,7 @@
           <a:bodyPr wrap="square" lIns="0" tIns="0" rIns="0" bIns="0" rtlCol="0" anchor="t"/>
           <a:lstStyle/>
           <a:p>
-            <a:pPr algn="ctr" indent="0" marL="0">
+            <a:pPr marL="0" indent="0" algn="ctr">
               <a:buNone/>
             </a:pPr>
             <a:r>
@@ -3172,6 +2796,7 @@
         <a:solidFill>
           <a:srgbClr val="0F172A"/>
         </a:solidFill>
+        <a:effectLst/>
       </p:bgPr>
     </p:bg>
     <p:spTree>
@@ -3209,7 +2834,7 @@
           <a:bodyPr wrap="square" lIns="0" tIns="0" rIns="0" bIns="0" rtlCol="0" anchor="t"/>
           <a:lstStyle/>
           <a:p>
-            <a:pPr algn="l" indent="0" marL="0">
+            <a:pPr marL="0" indent="0" algn="l">
               <a:buNone/>
             </a:pPr>
             <a:r>
@@ -3248,7 +2873,7 @@
           <a:bodyPr wrap="square" lIns="0" tIns="0" rIns="0" bIns="0" rtlCol="0" anchor="t"/>
           <a:lstStyle/>
           <a:p>
-            <a:pPr algn="l" indent="0" marL="0">
+            <a:pPr marL="0" indent="0" algn="l">
               <a:spcBef>
                 <a:spcPts val="300"/>
               </a:spcBef>
@@ -3290,7 +2915,7 @@
           <a:bodyPr wrap="square" lIns="0" tIns="0" rIns="0" bIns="0" rtlCol="0" anchor="t"/>
           <a:lstStyle/>
           <a:p>
-            <a:pPr algn="l" indent="0" marL="0">
+            <a:pPr marL="0" indent="0" algn="l">
               <a:buNone/>
             </a:pPr>
             <a:r>
@@ -3337,7 +2962,7 @@
           <a:bodyPr wrap="square" rtlCol="0" anchor="ctr"/>
           <a:lstStyle/>
           <a:p>
-            <a:pPr indent="0" marL="0">
+            <a:pPr marL="0" indent="0">
               <a:buNone/>
             </a:pPr>
             <a:endParaRPr lang="en-US" dirty="0"/>
@@ -3346,14 +2971,14 @@
       </p:sp>
       <p:pic>
         <p:nvPicPr>
-          <p:cNvPr id="6" name="Image 0" descr="/tmp/claude-1000/-home-nodozi-projects-NEBIUS-MAR-2026-Nebius-serverless-llm-experiments-lab/c5359c07-1207-4b10-b30c-fa9e048bfd83/scratchpad/pptx/icons/server.png">    </p:cNvPr>
+          <p:cNvPr id="6" name="Image 0" descr="/tmp/claude-1000/-home-nodozi-projects-NEBIUS-MAR-2026-Nebius-serverless-llm-experiments-lab/c5359c07-1207-4b10-b30c-fa9e048bfd83/scratchpad/pptx/icons/server.png"/>
           <p:cNvPicPr>
             <a:picLocks noChangeAspect="1"/>
           </p:cNvPicPr>
           <p:nvPr/>
         </p:nvPicPr>
         <p:blipFill>
-          <a:blip r:embed="rId1"/>
+          <a:blip r:embed="rId3"/>
           <a:stretch>
             <a:fillRect/>
           </a:stretch>
@@ -3389,7 +3014,7 @@
           <a:bodyPr wrap="square" lIns="0" tIns="0" rIns="0" bIns="0" rtlCol="0" anchor="t"/>
           <a:lstStyle/>
           <a:p>
-            <a:pPr algn="l" indent="0" marL="0">
+            <a:pPr marL="0" indent="0" algn="l">
               <a:spcAft>
                 <a:spcPts val="400"/>
               </a:spcAft>
@@ -3431,7 +3056,7 @@
           <a:bodyPr wrap="square" lIns="0" tIns="0" rIns="0" bIns="0" rtlCol="0" anchor="t"/>
           <a:lstStyle/>
           <a:p>
-            <a:pPr algn="l" indent="0" marL="0">
+            <a:pPr marL="0" indent="0" algn="l">
               <a:lnSpc>
                 <a:spcPts val="1209"/>
               </a:lnSpc>
@@ -3481,7 +3106,7 @@
           <a:bodyPr wrap="square" rtlCol="0" anchor="ctr"/>
           <a:lstStyle/>
           <a:p>
-            <a:pPr indent="0" marL="0">
+            <a:pPr marL="0" indent="0">
               <a:buNone/>
             </a:pPr>
             <a:endParaRPr lang="en-US" dirty="0"/>
@@ -3490,14 +3115,14 @@
       </p:sp>
       <p:pic>
         <p:nvPicPr>
-          <p:cNvPr id="10" name="Image 1" descr="/tmp/claude-1000/-home-nodozi-projects-NEBIUS-MAR-2026-Nebius-serverless-llm-experiments-lab/c5359c07-1207-4b10-b30c-fa9e048bfd83/scratchpad/pptx/icons/inspect.png">    </p:cNvPr>
+          <p:cNvPr id="10" name="Image 1" descr="/tmp/claude-1000/-home-nodozi-projects-NEBIUS-MAR-2026-Nebius-serverless-llm-experiments-lab/c5359c07-1207-4b10-b30c-fa9e048bfd83/scratchpad/pptx/icons/inspect.png"/>
           <p:cNvPicPr>
             <a:picLocks noChangeAspect="1"/>
           </p:cNvPicPr>
           <p:nvPr/>
         </p:nvPicPr>
         <p:blipFill>
-          <a:blip r:embed="rId2"/>
+          <a:blip r:embed="rId4"/>
           <a:stretch>
             <a:fillRect/>
           </a:stretch>
@@ -3533,7 +3158,7 @@
           <a:bodyPr wrap="square" lIns="0" tIns="0" rIns="0" bIns="0" rtlCol="0" anchor="t"/>
           <a:lstStyle/>
           <a:p>
-            <a:pPr algn="l" indent="0" marL="0">
+            <a:pPr marL="0" indent="0" algn="l">
               <a:spcAft>
                 <a:spcPts val="400"/>
               </a:spcAft>
@@ -3575,7 +3200,7 @@
           <a:bodyPr wrap="square" lIns="0" tIns="0" rIns="0" bIns="0" rtlCol="0" anchor="t"/>
           <a:lstStyle/>
           <a:p>
-            <a:pPr algn="l" indent="0" marL="0">
+            <a:pPr marL="0" indent="0" algn="l">
               <a:lnSpc>
                 <a:spcPts val="1209"/>
               </a:lnSpc>
@@ -3625,7 +3250,7 @@
           <a:bodyPr wrap="square" rtlCol="0" anchor="ctr"/>
           <a:lstStyle/>
           <a:p>
-            <a:pPr indent="0" marL="0">
+            <a:pPr marL="0" indent="0">
               <a:buNone/>
             </a:pPr>
             <a:endParaRPr lang="en-US" dirty="0"/>
@@ -3634,14 +3259,14 @@
       </p:sp>
       <p:pic>
         <p:nvPicPr>
-          <p:cNvPr id="14" name="Image 2" descr="/tmp/claude-1000/-home-nodozi-projects-NEBIUS-MAR-2026-Nebius-serverless-llm-experiments-lab/c5359c07-1207-4b10-b30c-fa9e048bfd83/scratchpad/pptx/icons/leaf.png">    </p:cNvPr>
+          <p:cNvPr id="14" name="Image 2" descr="/tmp/claude-1000/-home-nodozi-projects-NEBIUS-MAR-2026-Nebius-serverless-llm-experiments-lab/c5359c07-1207-4b10-b30c-fa9e048bfd83/scratchpad/pptx/icons/leaf.png"/>
           <p:cNvPicPr>
             <a:picLocks noChangeAspect="1"/>
           </p:cNvPicPr>
           <p:nvPr/>
         </p:nvPicPr>
         <p:blipFill>
-          <a:blip r:embed="rId3"/>
+          <a:blip r:embed="rId5"/>
           <a:stretch>
             <a:fillRect/>
           </a:stretch>
@@ -3677,7 +3302,7 @@
           <a:bodyPr wrap="square" lIns="0" tIns="0" rIns="0" bIns="0" rtlCol="0" anchor="t"/>
           <a:lstStyle/>
           <a:p>
-            <a:pPr algn="l" indent="0" marL="0">
+            <a:pPr marL="0" indent="0" algn="l">
               <a:spcAft>
                 <a:spcPts val="400"/>
               </a:spcAft>
@@ -3719,7 +3344,7 @@
           <a:bodyPr wrap="square" lIns="0" tIns="0" rIns="0" bIns="0" rtlCol="0" anchor="t"/>
           <a:lstStyle/>
           <a:p>
-            <a:pPr algn="l" indent="0" marL="0">
+            <a:pPr marL="0" indent="0" algn="l">
               <a:lnSpc>
                 <a:spcPts val="1209"/>
               </a:lnSpc>
@@ -3769,7 +3394,7 @@
           <a:bodyPr wrap="square" rtlCol="0" anchor="ctr"/>
           <a:lstStyle/>
           <a:p>
-            <a:pPr indent="0" marL="0">
+            <a:pPr marL="0" indent="0">
               <a:buNone/>
             </a:pPr>
             <a:endParaRPr lang="en-US" dirty="0"/>
@@ -3778,14 +3403,14 @@
       </p:sp>
       <p:pic>
         <p:nvPicPr>
-          <p:cNvPr id="18" name="Image 3" descr="/tmp/claude-1000/-home-nodozi-projects-NEBIUS-MAR-2026-Nebius-serverless-llm-experiments-lab/c5359c07-1207-4b10-b30c-fa9e048bfd83/scratchpad/pptx/icons/cloud.png">    </p:cNvPr>
+          <p:cNvPr id="18" name="Image 3" descr="/tmp/claude-1000/-home-nodozi-projects-NEBIUS-MAR-2026-Nebius-serverless-llm-experiments-lab/c5359c07-1207-4b10-b30c-fa9e048bfd83/scratchpad/pptx/icons/cloud.png"/>
           <p:cNvPicPr>
             <a:picLocks noChangeAspect="1"/>
           </p:cNvPicPr>
           <p:nvPr/>
         </p:nvPicPr>
         <p:blipFill>
-          <a:blip r:embed="rId4"/>
+          <a:blip r:embed="rId6"/>
           <a:stretch>
             <a:fillRect/>
           </a:stretch>
@@ -3821,7 +3446,7 @@
           <a:bodyPr wrap="square" lIns="0" tIns="0" rIns="0" bIns="0" rtlCol="0" anchor="t"/>
           <a:lstStyle/>
           <a:p>
-            <a:pPr algn="l" indent="0" marL="0">
+            <a:pPr marL="0" indent="0" algn="l">
               <a:spcAft>
                 <a:spcPts val="400"/>
               </a:spcAft>
@@ -3863,7 +3488,7 @@
           <a:bodyPr wrap="square" lIns="0" tIns="0" rIns="0" bIns="0" rtlCol="0" anchor="t"/>
           <a:lstStyle/>
           <a:p>
-            <a:pPr algn="l" indent="0" marL="0">
+            <a:pPr marL="0" indent="0" algn="l">
               <a:lnSpc>
                 <a:spcPts val="1209"/>
               </a:lnSpc>
@@ -3913,7 +3538,7 @@
           <a:bodyPr wrap="square" rtlCol="0" anchor="ctr"/>
           <a:lstStyle/>
           <a:p>
-            <a:pPr indent="0" marL="0">
+            <a:pPr marL="0" indent="0">
               <a:buNone/>
             </a:pPr>
             <a:endParaRPr lang="en-US" dirty="0"/>
@@ -3922,14 +3547,14 @@
       </p:sp>
       <p:pic>
         <p:nvPicPr>
-          <p:cNvPr id="22" name="Image 4" descr="/tmp/claude-1000/-home-nodozi-projects-NEBIUS-MAR-2026-Nebius-serverless-llm-experiments-lab/c5359c07-1207-4b10-b30c-fa9e048bfd83/scratchpad/pptx/icons/check.png">    </p:cNvPr>
+          <p:cNvPr id="22" name="Image 4" descr="/tmp/claude-1000/-home-nodozi-projects-NEBIUS-MAR-2026-Nebius-serverless-llm-experiments-lab/c5359c07-1207-4b10-b30c-fa9e048bfd83/scratchpad/pptx/icons/check.png"/>
           <p:cNvPicPr>
             <a:picLocks noChangeAspect="1"/>
           </p:cNvPicPr>
           <p:nvPr/>
         </p:nvPicPr>
         <p:blipFill>
-          <a:blip r:embed="rId5"/>
+          <a:blip r:embed="rId7"/>
           <a:stretch>
             <a:fillRect/>
           </a:stretch>
@@ -3965,7 +3590,7 @@
           <a:bodyPr wrap="square" lIns="0" tIns="0" rIns="0" bIns="0" rtlCol="0" anchor="t"/>
           <a:lstStyle/>
           <a:p>
-            <a:pPr algn="l" indent="0" marL="0">
+            <a:pPr marL="0" indent="0" algn="l">
               <a:spcAft>
                 <a:spcPts val="400"/>
               </a:spcAft>
@@ -4007,7 +3632,7 @@
           <a:bodyPr wrap="square" lIns="0" tIns="0" rIns="0" bIns="0" rtlCol="0" anchor="t"/>
           <a:lstStyle/>
           <a:p>
-            <a:pPr algn="l" indent="0" marL="0">
+            <a:pPr marL="0" indent="0" algn="l">
               <a:lnSpc>
                 <a:spcPts val="1209"/>
               </a:lnSpc>
@@ -4057,7 +3682,7 @@
           <a:bodyPr wrap="square" rtlCol="0" anchor="ctr"/>
           <a:lstStyle/>
           <a:p>
-            <a:pPr indent="0" marL="0">
+            <a:pPr marL="0" indent="0">
               <a:buNone/>
             </a:pPr>
             <a:endParaRPr lang="en-US" dirty="0"/>
@@ -4066,14 +3691,14 @@
       </p:sp>
       <p:pic>
         <p:nvPicPr>
-          <p:cNvPr id="26" name="Image 5" descr="/tmp/claude-1000/-home-nodozi-projects-NEBIUS-MAR-2026-Nebius-serverless-llm-experiments-lab/c5359c07-1207-4b10-b30c-fa9e048bfd83/scratchpad/pptx/icons/lock.png">    </p:cNvPr>
+          <p:cNvPr id="26" name="Image 5" descr="/tmp/claude-1000/-home-nodozi-projects-NEBIUS-MAR-2026-Nebius-serverless-llm-experiments-lab/c5359c07-1207-4b10-b30c-fa9e048bfd83/scratchpad/pptx/icons/lock.png"/>
           <p:cNvPicPr>
             <a:picLocks noChangeAspect="1"/>
           </p:cNvPicPr>
           <p:nvPr/>
         </p:nvPicPr>
         <p:blipFill>
-          <a:blip r:embed="rId6"/>
+          <a:blip r:embed="rId8"/>
           <a:stretch>
             <a:fillRect/>
           </a:stretch>
@@ -4109,7 +3734,7 @@
           <a:bodyPr wrap="square" lIns="0" tIns="0" rIns="0" bIns="0" rtlCol="0" anchor="t"/>
           <a:lstStyle/>
           <a:p>
-            <a:pPr algn="l" indent="0" marL="0">
+            <a:pPr marL="0" indent="0" algn="l">
               <a:spcAft>
                 <a:spcPts val="400"/>
               </a:spcAft>
@@ -4151,7 +3776,7 @@
           <a:bodyPr wrap="square" lIns="0" tIns="0" rIns="0" bIns="0" rtlCol="0" anchor="t"/>
           <a:lstStyle/>
           <a:p>
-            <a:pPr algn="l" indent="0" marL="0">
+            <a:pPr marL="0" indent="0" algn="l">
               <a:lnSpc>
                 <a:spcPts val="1209"/>
               </a:lnSpc>
@@ -4182,12 +3807,13 @@
 
 <file path=ppt/slides/slide5.xml><?xml version="1.0" encoding="utf-8"?>
 <p:sld xmlns:a="http://schemas.openxmlformats.org/drawingml/2006/main" xmlns:r="http://schemas.openxmlformats.org/officeDocument/2006/relationships" xmlns:p="http://schemas.openxmlformats.org/presentationml/2006/main">
-  <p:cSld name="Slide 5">
+  <p:cSld name="Slide 6">
     <p:bg>
       <p:bgPr>
         <a:solidFill>
           <a:srgbClr val="0F172A"/>
         </a:solidFill>
+        <a:effectLst/>
       </p:bgPr>
     </p:bg>
     <p:spTree>
@@ -4212,20 +3838,20 @@
         </p:nvSpPr>
         <p:spPr>
           <a:xfrm>
-            <a:off x="507950" y="381000"/>
-            <a:ext cx="4922419" cy="171450"/>
-          </a:xfrm>
-          <a:prstGeom prst="rect">
-            <a:avLst/>
-          </a:prstGeom>
-          <a:noFill/>
-          <a:ln/>
-        </p:spPr>
-        <p:txBody>
-          <a:bodyPr wrap="square" lIns="0" tIns="0" rIns="0" bIns="0" rtlCol="0" anchor="t"/>
-          <a:lstStyle/>
-          <a:p>
-            <a:pPr algn="l" indent="0" marL="0">
+            <a:off x="507950" y="355550"/>
+            <a:ext cx="8808771" cy="171450"/>
+          </a:xfrm>
+          <a:prstGeom prst="rect">
+            <a:avLst/>
+          </a:prstGeom>
+          <a:noFill/>
+          <a:ln/>
+        </p:spPr>
+        <p:txBody>
+          <a:bodyPr wrap="square" lIns="0" tIns="0" rIns="0" bIns="0" rtlCol="0" anchor="t"/>
+          <a:lstStyle/>
+          <a:p>
+            <a:pPr marL="0" indent="0" algn="l">
               <a:buNone/>
             </a:pPr>
             <a:r>
@@ -4237,7 +3863,7 @@
                 <a:ea typeface="Arial" pitchFamily="34" charset="-122"/>
                 <a:cs typeface="Arial" pitchFamily="34" charset="-120"/>
               </a:rPr>
-              <a:t>RESULTS</a:t>
+              <a:t>LEARNINGS &amp; DISCOVERIES</a:t>
             </a:r>
             <a:endParaRPr lang="en-US" sz="1200" dirty="0"/>
           </a:p>
@@ -4251,30 +3877,27 @@
         </p:nvSpPr>
         <p:spPr>
           <a:xfrm>
-            <a:off x="507950" y="603200"/>
-            <a:ext cx="4922419" cy="371475"/>
-          </a:xfrm>
-          <a:prstGeom prst="rect">
-            <a:avLst/>
-          </a:prstGeom>
-          <a:noFill/>
-          <a:ln/>
-        </p:spPr>
-        <p:txBody>
-          <a:bodyPr wrap="square" lIns="0" tIns="0" rIns="0" bIns="0" rtlCol="0" anchor="t"/>
-          <a:lstStyle/>
-          <a:p>
-            <a:pPr algn="l" indent="0" marL="0">
+            <a:off x="507950" y="577751"/>
+            <a:ext cx="8808771" cy="361950"/>
+          </a:xfrm>
+          <a:prstGeom prst="rect">
+            <a:avLst/>
+          </a:prstGeom>
+          <a:noFill/>
+          <a:ln/>
+        </p:spPr>
+        <p:txBody>
+          <a:bodyPr wrap="square" lIns="0" tIns="0" rIns="0" bIns="0" rtlCol="0" anchor="t"/>
+          <a:lstStyle/>
+          <a:p>
+            <a:pPr marL="0" indent="0" algn="l">
               <a:spcBef>
                 <a:spcPts val="400"/>
               </a:spcBef>
-              <a:spcAft>
-                <a:spcPts val="1600"/>
-              </a:spcAft>
-              <a:buNone/>
-            </a:pPr>
-            <a:r>
-              <a:rPr lang="en-US" sz="2600" b="1" dirty="0">
+              <a:buNone/>
+            </a:pPr>
+            <a:r>
+              <a:rPr lang="en-US" sz="2500" b="1" dirty="0">
                 <a:solidFill>
                   <a:srgbClr val="FFFFFF"/>
                 </a:solidFill>
@@ -4282,837 +3905,15 @@
                 <a:ea typeface="Arial" pitchFamily="34" charset="-122"/>
                 <a:cs typeface="Arial" pitchFamily="34" charset="-120"/>
               </a:rPr>
-              <a:t>What actually works</a:t>
-            </a:r>
-            <a:endParaRPr lang="en-US" sz="2600" dirty="0"/>
-          </a:p>
-        </p:txBody>
-      </p:sp>
-      <p:sp>
-        <p:nvSpPr>
-          <p:cNvPr id="4" name="Text 2"/>
-          <p:cNvSpPr/>
-          <p:nvPr/>
-        </p:nvSpPr>
-        <p:spPr>
-          <a:xfrm>
-            <a:off x="507950" y="1177826"/>
-            <a:ext cx="2222450" cy="986730"/>
-          </a:xfrm>
-          <a:prstGeom prst="roundRect">
-            <a:avLst>
-              <a:gd name="adj" fmla="val 10297"/>
-            </a:avLst>
-          </a:prstGeom>
-          <a:solidFill>
-            <a:srgbClr val="1E293B"/>
-          </a:solidFill>
-          <a:ln w="9525">
-            <a:solidFill>
-              <a:srgbClr val="334155"/>
-            </a:solidFill>
-          </a:ln>
-        </p:spPr>
-        <p:txBody>
-          <a:bodyPr wrap="square" rtlCol="0" anchor="ctr"/>
-          <a:lstStyle/>
-          <a:p>
-            <a:pPr indent="0" marL="0">
-              <a:buNone/>
-            </a:pPr>
-            <a:endParaRPr lang="en-US" dirty="0"/>
-          </a:p>
-        </p:txBody>
-      </p:sp>
-      <p:sp>
-        <p:nvSpPr>
-          <p:cNvPr id="5" name="Text 3"/>
-          <p:cNvSpPr/>
-          <p:nvPr/>
-        </p:nvSpPr>
-        <p:spPr>
-          <a:xfrm>
-            <a:off x="695176" y="1339751"/>
-            <a:ext cx="1884959" cy="323850"/>
-          </a:xfrm>
-          <a:prstGeom prst="rect">
-            <a:avLst/>
-          </a:prstGeom>
-          <a:noFill/>
-          <a:ln/>
-        </p:spPr>
-        <p:txBody>
-          <a:bodyPr wrap="square" lIns="0" tIns="0" rIns="0" bIns="0" rtlCol="0" anchor="t"/>
-          <a:lstStyle/>
-          <a:p>
-            <a:pPr algn="l" indent="0" marL="0">
-              <a:buNone/>
-            </a:pPr>
-            <a:r>
-              <a:rPr lang="en-US" sz="2200" b="1" dirty="0">
-                <a:solidFill>
-                  <a:srgbClr val="4ADE80"/>
-                </a:solidFill>
-                <a:latin typeface="Arial" pitchFamily="34" charset="0"/>
-                <a:ea typeface="Arial" pitchFamily="34" charset="-122"/>
-                <a:cs typeface="Arial" pitchFamily="34" charset="-120"/>
-              </a:rPr>
-              <a:t>255</a:t>
-            </a:r>
-            <a:endParaRPr lang="en-US" sz="2200" dirty="0"/>
-          </a:p>
-        </p:txBody>
-      </p:sp>
-      <p:sp>
-        <p:nvSpPr>
-          <p:cNvPr id="6" name="Text 4"/>
-          <p:cNvSpPr/>
-          <p:nvPr/>
-        </p:nvSpPr>
-        <p:spPr>
-          <a:xfrm>
-            <a:off x="695176" y="1688902"/>
-            <a:ext cx="1884959" cy="313730"/>
-          </a:xfrm>
-          <a:prstGeom prst="rect">
-            <a:avLst/>
-          </a:prstGeom>
-          <a:noFill/>
-          <a:ln/>
-        </p:spPr>
-        <p:txBody>
-          <a:bodyPr wrap="square" lIns="0" tIns="0" rIns="0" bIns="0" rtlCol="0" anchor="t"/>
-          <a:lstStyle/>
-          <a:p>
-            <a:pPr algn="l" indent="0" marL="0">
-              <a:lnSpc>
-                <a:spcPts val="1235"/>
-              </a:lnSpc>
-              <a:spcBef>
-                <a:spcPts val="200"/>
-              </a:spcBef>
-              <a:buNone/>
-            </a:pPr>
-            <a:r>
-              <a:rPr lang="en-US" sz="950" dirty="0">
-                <a:solidFill>
-                  <a:srgbClr val="94A3B8"/>
-                </a:solidFill>
-                <a:latin typeface="Arial" pitchFamily="34" charset="0"/>
-                <a:ea typeface="Arial" pitchFamily="34" charset="-122"/>
-                <a:cs typeface="Arial" pitchFamily="34" charset="-120"/>
-              </a:rPr>
-              <a:t>tests passing (203 backend + 52 frontend)</a:t>
-            </a:r>
-            <a:endParaRPr lang="en-US" sz="950" dirty="0"/>
-          </a:p>
-        </p:txBody>
-      </p:sp>
-      <p:sp>
-        <p:nvSpPr>
-          <p:cNvPr id="7" name="Text 5"/>
-          <p:cNvSpPr/>
-          <p:nvPr/>
-        </p:nvSpPr>
-        <p:spPr>
-          <a:xfrm>
-            <a:off x="2882801" y="1177826"/>
-            <a:ext cx="2222450" cy="986730"/>
-          </a:xfrm>
-          <a:prstGeom prst="roundRect">
-            <a:avLst>
-              <a:gd name="adj" fmla="val 10297"/>
-            </a:avLst>
-          </a:prstGeom>
-          <a:solidFill>
-            <a:srgbClr val="1E293B"/>
-          </a:solidFill>
-          <a:ln w="9525">
-            <a:solidFill>
-              <a:srgbClr val="334155"/>
-            </a:solidFill>
-          </a:ln>
-        </p:spPr>
-        <p:txBody>
-          <a:bodyPr wrap="square" rtlCol="0" anchor="ctr"/>
-          <a:lstStyle/>
-          <a:p>
-            <a:pPr indent="0" marL="0">
-              <a:buNone/>
-            </a:pPr>
-            <a:endParaRPr lang="en-US" dirty="0"/>
-          </a:p>
-        </p:txBody>
-      </p:sp>
-      <p:sp>
-        <p:nvSpPr>
-          <p:cNvPr id="8" name="Text 6"/>
-          <p:cNvSpPr/>
-          <p:nvPr/>
-        </p:nvSpPr>
-        <p:spPr>
-          <a:xfrm>
-            <a:off x="3070027" y="1339751"/>
-            <a:ext cx="1884959" cy="323850"/>
-          </a:xfrm>
-          <a:prstGeom prst="rect">
-            <a:avLst/>
-          </a:prstGeom>
-          <a:noFill/>
-          <a:ln/>
-        </p:spPr>
-        <p:txBody>
-          <a:bodyPr wrap="square" lIns="0" tIns="0" rIns="0" bIns="0" rtlCol="0" anchor="t"/>
-          <a:lstStyle/>
-          <a:p>
-            <a:pPr algn="l" indent="0" marL="0">
-              <a:buNone/>
-            </a:pPr>
-            <a:r>
-              <a:rPr lang="en-US" sz="2200" b="1" dirty="0">
-                <a:solidFill>
-                  <a:srgbClr val="4ADE80"/>
-                </a:solidFill>
-                <a:latin typeface="Arial" pitchFamily="34" charset="0"/>
-                <a:ea typeface="Arial" pitchFamily="34" charset="-122"/>
-                <a:cs typeface="Arial" pitchFamily="34" charset="-120"/>
-              </a:rPr>
-              <a:t>4</a:t>
-            </a:r>
-            <a:endParaRPr lang="en-US" sz="2200" dirty="0"/>
-          </a:p>
-        </p:txBody>
-      </p:sp>
-      <p:sp>
-        <p:nvSpPr>
-          <p:cNvPr id="9" name="Text 7"/>
-          <p:cNvSpPr/>
-          <p:nvPr/>
-        </p:nvSpPr>
-        <p:spPr>
-          <a:xfrm>
-            <a:off x="3070027" y="1688902"/>
-            <a:ext cx="1884959" cy="313730"/>
-          </a:xfrm>
-          <a:prstGeom prst="rect">
-            <a:avLst/>
-          </a:prstGeom>
-          <a:noFill/>
-          <a:ln/>
-        </p:spPr>
-        <p:txBody>
-          <a:bodyPr wrap="square" lIns="0" tIns="0" rIns="0" bIns="0" rtlCol="0" anchor="t"/>
-          <a:lstStyle/>
-          <a:p>
-            <a:pPr algn="l" indent="0" marL="0">
-              <a:lnSpc>
-                <a:spcPts val="1235"/>
-              </a:lnSpc>
-              <a:spcBef>
-                <a:spcPts val="200"/>
-              </a:spcBef>
-              <a:buNone/>
-            </a:pPr>
-            <a:r>
-              <a:rPr lang="en-US" sz="950" dirty="0">
-                <a:solidFill>
-                  <a:srgbClr val="94A3B8"/>
-                </a:solidFill>
-                <a:latin typeface="Arial" pitchFamily="34" charset="0"/>
-                <a:ea typeface="Arial" pitchFamily="34" charset="-122"/>
-                <a:cs typeface="Arial" pitchFamily="34" charset="-120"/>
-              </a:rPr>
-              <a:t>model presets live: Transformer, MoE, RNN, High-LR</a:t>
-            </a:r>
-            <a:endParaRPr lang="en-US" sz="950" dirty="0"/>
-          </a:p>
-        </p:txBody>
-      </p:sp>
-      <p:sp>
-        <p:nvSpPr>
-          <p:cNvPr id="10" name="Text 8"/>
-          <p:cNvSpPr/>
-          <p:nvPr/>
-        </p:nvSpPr>
-        <p:spPr>
-          <a:xfrm>
-            <a:off x="507950" y="2316956"/>
-            <a:ext cx="2222450" cy="986730"/>
-          </a:xfrm>
-          <a:prstGeom prst="roundRect">
-            <a:avLst>
-              <a:gd name="adj" fmla="val 10297"/>
-            </a:avLst>
-          </a:prstGeom>
-          <a:solidFill>
-            <a:srgbClr val="1E293B"/>
-          </a:solidFill>
-          <a:ln w="9525">
-            <a:solidFill>
-              <a:srgbClr val="334155"/>
-            </a:solidFill>
-          </a:ln>
-        </p:spPr>
-        <p:txBody>
-          <a:bodyPr wrap="square" rtlCol="0" anchor="ctr"/>
-          <a:lstStyle/>
-          <a:p>
-            <a:pPr indent="0" marL="0">
-              <a:buNone/>
-            </a:pPr>
-            <a:endParaRPr lang="en-US" dirty="0"/>
-          </a:p>
-        </p:txBody>
-      </p:sp>
-      <p:sp>
-        <p:nvSpPr>
-          <p:cNvPr id="11" name="Text 9"/>
-          <p:cNvSpPr/>
-          <p:nvPr/>
-        </p:nvSpPr>
-        <p:spPr>
-          <a:xfrm>
-            <a:off x="695176" y="2478881"/>
-            <a:ext cx="1884959" cy="323850"/>
-          </a:xfrm>
-          <a:prstGeom prst="rect">
-            <a:avLst/>
-          </a:prstGeom>
-          <a:noFill/>
-          <a:ln/>
-        </p:spPr>
-        <p:txBody>
-          <a:bodyPr wrap="square" lIns="0" tIns="0" rIns="0" bIns="0" rtlCol="0" anchor="t"/>
-          <a:lstStyle/>
-          <a:p>
-            <a:pPr algn="l" indent="0" marL="0">
-              <a:buNone/>
-            </a:pPr>
-            <a:r>
-              <a:rPr lang="en-US" sz="2200" b="1" dirty="0">
-                <a:solidFill>
-                  <a:srgbClr val="4ADE80"/>
-                </a:solidFill>
-                <a:latin typeface="Arial" pitchFamily="34" charset="0"/>
-                <a:ea typeface="Arial" pitchFamily="34" charset="-122"/>
-                <a:cs typeface="Arial" pitchFamily="34" charset="-120"/>
-              </a:rPr>
-              <a:t>~$5</a:t>
-            </a:r>
-            <a:endParaRPr lang="en-US" sz="2200" dirty="0"/>
-          </a:p>
-        </p:txBody>
-      </p:sp>
-      <p:sp>
-        <p:nvSpPr>
-          <p:cNvPr id="12" name="Text 10"/>
-          <p:cNvSpPr/>
-          <p:nvPr/>
-        </p:nvSpPr>
-        <p:spPr>
-          <a:xfrm>
-            <a:off x="695176" y="2828032"/>
-            <a:ext cx="1884959" cy="313730"/>
-          </a:xfrm>
-          <a:prstGeom prst="rect">
-            <a:avLst/>
-          </a:prstGeom>
-          <a:noFill/>
-          <a:ln/>
-        </p:spPr>
-        <p:txBody>
-          <a:bodyPr wrap="square" lIns="0" tIns="0" rIns="0" bIns="0" rtlCol="0" anchor="t"/>
-          <a:lstStyle/>
-          <a:p>
-            <a:pPr algn="l" indent="0" marL="0">
-              <a:lnSpc>
-                <a:spcPts val="1235"/>
-              </a:lnSpc>
-              <a:spcBef>
-                <a:spcPts val="200"/>
-              </a:spcBef>
-              <a:buNone/>
-            </a:pPr>
-            <a:r>
-              <a:rPr lang="en-US" sz="950" dirty="0">
-                <a:solidFill>
-                  <a:srgbClr val="94A3B8"/>
-                </a:solidFill>
-                <a:latin typeface="Arial" pitchFamily="34" charset="0"/>
-                <a:ea typeface="Arial" pitchFamily="34" charset="-122"/>
-                <a:cs typeface="Arial" pitchFamily="34" charset="-120"/>
-              </a:rPr>
-              <a:t>for a full GPU session — start, train, prompt, review</a:t>
-            </a:r>
-            <a:endParaRPr lang="en-US" sz="950" dirty="0"/>
-          </a:p>
-        </p:txBody>
-      </p:sp>
-      <p:sp>
-        <p:nvSpPr>
-          <p:cNvPr id="13" name="Text 11"/>
-          <p:cNvSpPr/>
-          <p:nvPr/>
-        </p:nvSpPr>
-        <p:spPr>
-          <a:xfrm>
-            <a:off x="2882801" y="2316956"/>
-            <a:ext cx="2222450" cy="986730"/>
-          </a:xfrm>
-          <a:prstGeom prst="roundRect">
-            <a:avLst>
-              <a:gd name="adj" fmla="val 10297"/>
-            </a:avLst>
-          </a:prstGeom>
-          <a:solidFill>
-            <a:srgbClr val="1E293B"/>
-          </a:solidFill>
-          <a:ln w="9525">
-            <a:solidFill>
-              <a:srgbClr val="334155"/>
-            </a:solidFill>
-          </a:ln>
-        </p:spPr>
-        <p:txBody>
-          <a:bodyPr wrap="square" rtlCol="0" anchor="ctr"/>
-          <a:lstStyle/>
-          <a:p>
-            <a:pPr indent="0" marL="0">
-              <a:buNone/>
-            </a:pPr>
-            <a:endParaRPr lang="en-US" dirty="0"/>
-          </a:p>
-        </p:txBody>
-      </p:sp>
-      <p:sp>
-        <p:nvSpPr>
-          <p:cNvPr id="14" name="Text 12"/>
-          <p:cNvSpPr/>
-          <p:nvPr/>
-        </p:nvSpPr>
-        <p:spPr>
-          <a:xfrm>
-            <a:off x="3070027" y="2478881"/>
-            <a:ext cx="1884959" cy="323850"/>
-          </a:xfrm>
-          <a:prstGeom prst="rect">
-            <a:avLst/>
-          </a:prstGeom>
-          <a:noFill/>
-          <a:ln/>
-        </p:spPr>
-        <p:txBody>
-          <a:bodyPr wrap="square" lIns="0" tIns="0" rIns="0" bIns="0" rtlCol="0" anchor="t"/>
-          <a:lstStyle/>
-          <a:p>
-            <a:pPr algn="l" indent="0" marL="0">
-              <a:buNone/>
-            </a:pPr>
-            <a:r>
-              <a:rPr lang="en-US" sz="2200" b="1" dirty="0">
-                <a:solidFill>
-                  <a:srgbClr val="4ADE80"/>
-                </a:solidFill>
-                <a:latin typeface="Arial" pitchFamily="34" charset="0"/>
-                <a:ea typeface="Arial" pitchFamily="34" charset="-122"/>
-                <a:cs typeface="Arial" pitchFamily="34" charset="-120"/>
-              </a:rPr>
-              <a:t>2</a:t>
-            </a:r>
-            <a:endParaRPr lang="en-US" sz="2200" dirty="0"/>
-          </a:p>
-        </p:txBody>
-      </p:sp>
-      <p:sp>
-        <p:nvSpPr>
-          <p:cNvPr id="15" name="Text 13"/>
-          <p:cNvSpPr/>
-          <p:nvPr/>
-        </p:nvSpPr>
-        <p:spPr>
-          <a:xfrm>
-            <a:off x="3070027" y="2828032"/>
-            <a:ext cx="1884959" cy="313730"/>
-          </a:xfrm>
-          <a:prstGeom prst="rect">
-            <a:avLst/>
-          </a:prstGeom>
-          <a:noFill/>
-          <a:ln/>
-        </p:spPr>
-        <p:txBody>
-          <a:bodyPr wrap="square" lIns="0" tIns="0" rIns="0" bIns="0" rtlCol="0" anchor="t"/>
-          <a:lstStyle/>
-          <a:p>
-            <a:pPr algn="l" indent="0" marL="0">
-              <a:lnSpc>
-                <a:spcPts val="1235"/>
-              </a:lnSpc>
-              <a:spcBef>
-                <a:spcPts val="200"/>
-              </a:spcBef>
-              <a:buNone/>
-            </a:pPr>
-            <a:r>
-              <a:rPr lang="en-US" sz="950" dirty="0">
-                <a:solidFill>
-                  <a:srgbClr val="94A3B8"/>
-                </a:solidFill>
-                <a:latin typeface="Arial" pitchFamily="34" charset="0"/>
-                <a:ea typeface="Arial" pitchFamily="34" charset="-122"/>
-                <a:cs typeface="Arial" pitchFamily="34" charset="-120"/>
-              </a:rPr>
-              <a:t>concurrent runs sharing 1 warm CPU box, 0 drama</a:t>
-            </a:r>
-            <a:endParaRPr lang="en-US" sz="950" dirty="0"/>
+              <a:t>Things that bit us (so they won't bite you)</a:t>
+            </a:r>
+            <a:endParaRPr lang="en-US" sz="2500" dirty="0"/>
           </a:p>
         </p:txBody>
       </p:sp>
       <p:pic>
         <p:nvPicPr>
-          <p:cNvPr id="16" name="Image 0" descr="/tmp/claude-1000/-home-nodozi-projects-NEBIUS-MAR-2026-Nebius-serverless-llm-experiments-lab/c5359c07-1207-4b10-b30c-fa9e048bfd83/scratchpad/pptx/attention.png">    </p:cNvPr>
-          <p:cNvPicPr>
-            <a:picLocks noChangeAspect="1"/>
-          </p:cNvPicPr>
-          <p:nvPr/>
-        </p:nvPicPr>
-        <p:blipFill>
-          <a:blip r:embed="rId1"/>
-          <a:stretch>
-            <a:fillRect/>
-          </a:stretch>
-        </p:blipFill>
-        <p:spPr>
-          <a:xfrm>
-            <a:off x="6070402" y="431750"/>
-            <a:ext cx="1828800" cy="3810000"/>
-          </a:xfrm>
-          <a:prstGeom prst="rect">
-            <a:avLst/>
-          </a:prstGeom>
-        </p:spPr>
-      </p:pic>
-      <p:sp>
-        <p:nvSpPr>
-          <p:cNvPr id="17" name="Text 14"/>
-          <p:cNvSpPr/>
-          <p:nvPr/>
-        </p:nvSpPr>
-        <p:spPr>
-          <a:xfrm>
-            <a:off x="5300832" y="4343251"/>
-            <a:ext cx="3367939" cy="266700"/>
-          </a:xfrm>
-          <a:prstGeom prst="rect">
-            <a:avLst/>
-          </a:prstGeom>
-          <a:noFill/>
-          <a:ln/>
-        </p:spPr>
-        <p:txBody>
-          <a:bodyPr wrap="square" lIns="0" tIns="0" rIns="0" bIns="0" rtlCol="0" anchor="t"/>
-          <a:lstStyle/>
-          <a:p>
-            <a:pPr algn="ctr" indent="0" marL="0">
-              <a:buNone/>
-            </a:pPr>
-            <a:r>
-              <a:rPr lang="en-US" sz="950" dirty="0">
-                <a:solidFill>
-                  <a:srgbClr val="64748B"/>
-                </a:solidFill>
-                <a:latin typeface="Arial" pitchFamily="34" charset="0"/>
-                <a:ea typeface="Arial" pitchFamily="34" charset="-122"/>
-                <a:cs typeface="Arial" pitchFamily="34" charset="-120"/>
-              </a:rPr>
-              <a:t>The Inspector, live — causal self-attention and Q/K/V, one forward pass at a time.</a:t>
-            </a:r>
-            <a:endParaRPr lang="en-US" sz="950" dirty="0"/>
-          </a:p>
-        </p:txBody>
-      </p:sp>
-    </p:spTree>
-  </p:cSld>
-  <p:clrMapOvr>
-    <a:masterClrMapping/>
-  </p:clrMapOvr>
-</p:sld>
-</file>
-
-<file path=ppt/slides/slide6.xml><?xml version="1.0" encoding="utf-8"?>
-<p:sld xmlns:a="http://schemas.openxmlformats.org/drawingml/2006/main" xmlns:r="http://schemas.openxmlformats.org/officeDocument/2006/relationships" xmlns:p="http://schemas.openxmlformats.org/presentationml/2006/main">
-  <p:cSld name="Slide 6">
-    <p:bg>
-      <p:bgPr>
-        <a:solidFill>
-          <a:srgbClr val="0F172A"/>
-        </a:solidFill>
-      </p:bgPr>
-    </p:bg>
-    <p:spTree>
-      <p:nvGrpSpPr>
-        <p:cNvPr id="1" name=""/>
-        <p:cNvGrpSpPr/>
-        <p:nvPr/>
-      </p:nvGrpSpPr>
-      <p:grpSpPr>
-        <a:xfrm>
-          <a:off x="0" y="0"/>
-          <a:ext cx="0" cy="0"/>
-          <a:chOff x="0" y="0"/>
-          <a:chExt cx="0" cy="0"/>
-        </a:xfrm>
-      </p:grpSpPr>
-      <p:sp>
-        <p:nvSpPr>
-          <p:cNvPr id="2" name="Text 0"/>
-          <p:cNvSpPr/>
-          <p:nvPr/>
-        </p:nvSpPr>
-        <p:spPr>
-          <a:xfrm>
-            <a:off x="507950" y="355550"/>
-            <a:ext cx="8808771" cy="171450"/>
-          </a:xfrm>
-          <a:prstGeom prst="rect">
-            <a:avLst/>
-          </a:prstGeom>
-          <a:noFill/>
-          <a:ln/>
-        </p:spPr>
-        <p:txBody>
-          <a:bodyPr wrap="square" lIns="0" tIns="0" rIns="0" bIns="0" rtlCol="0" anchor="t"/>
-          <a:lstStyle/>
-          <a:p>
-            <a:pPr algn="l" indent="0" marL="0">
-              <a:buNone/>
-            </a:pPr>
-            <a:r>
-              <a:rPr lang="en-US" sz="1200" b="1" dirty="0">
-                <a:solidFill>
-                  <a:srgbClr val="38BDF8"/>
-                </a:solidFill>
-                <a:latin typeface="Arial" pitchFamily="34" charset="0"/>
-                <a:ea typeface="Arial" pitchFamily="34" charset="-122"/>
-                <a:cs typeface="Arial" pitchFamily="34" charset="-120"/>
-              </a:rPr>
-              <a:t>LEARNINGS &amp; DISCOVERIES</a:t>
-            </a:r>
-            <a:endParaRPr lang="en-US" sz="1200" dirty="0"/>
-          </a:p>
-        </p:txBody>
-      </p:sp>
-      <p:sp>
-        <p:nvSpPr>
-          <p:cNvPr id="3" name="Text 1"/>
-          <p:cNvSpPr/>
-          <p:nvPr/>
-        </p:nvSpPr>
-        <p:spPr>
-          <a:xfrm>
-            <a:off x="507950" y="577751"/>
-            <a:ext cx="8808771" cy="361950"/>
-          </a:xfrm>
-          <a:prstGeom prst="rect">
-            <a:avLst/>
-          </a:prstGeom>
-          <a:noFill/>
-          <a:ln/>
-        </p:spPr>
-        <p:txBody>
-          <a:bodyPr wrap="square" lIns="0" tIns="0" rIns="0" bIns="0" rtlCol="0" anchor="t"/>
-          <a:lstStyle/>
-          <a:p>
-            <a:pPr algn="l" indent="0" marL="0">
-              <a:spcBef>
-                <a:spcPts val="400"/>
-              </a:spcBef>
-              <a:buNone/>
-            </a:pPr>
-            <a:r>
-              <a:rPr lang="en-US" sz="2500" b="1" dirty="0">
-                <a:solidFill>
-                  <a:srgbClr val="FFFFFF"/>
-                </a:solidFill>
-                <a:latin typeface="Arial" pitchFamily="34" charset="0"/>
-                <a:ea typeface="Arial" pitchFamily="34" charset="-122"/>
-                <a:cs typeface="Arial" pitchFamily="34" charset="-120"/>
-              </a:rPr>
-              <a:t>Things that bit us (so they won't bite you)</a:t>
-            </a:r>
-            <a:endParaRPr lang="en-US" sz="2500" dirty="0"/>
-          </a:p>
-        </p:txBody>
-      </p:sp>
-      <p:pic>
-        <p:nvPicPr>
-          <p:cNvPr id="4" name="Image 0" descr="/tmp/claude-1000/-home-nodozi-projects-NEBIUS-MAR-2026-Nebius-serverless-llm-experiments-lab/c5359c07-1207-4b10-b30c-fa9e048bfd83/scratchpad/pptx/icons/bug.png">    </p:cNvPr>
-          <p:cNvPicPr>
-            <a:picLocks noChangeAspect="1"/>
-          </p:cNvPicPr>
-          <p:nvPr/>
-        </p:nvPicPr>
-        <p:blipFill>
-          <a:blip r:embed="rId1"/>
-          <a:stretch>
-            <a:fillRect/>
-          </a:stretch>
-        </p:blipFill>
-        <p:spPr>
-          <a:xfrm>
-            <a:off x="507950" y="1142702"/>
-            <a:ext cx="190500" cy="190500"/>
-          </a:xfrm>
-          <a:prstGeom prst="rect">
-            <a:avLst/>
-          </a:prstGeom>
-        </p:spPr>
-      </p:pic>
-      <p:sp>
-        <p:nvSpPr>
-          <p:cNvPr id="5" name="Text 2"/>
-          <p:cNvSpPr/>
-          <p:nvPr/>
-        </p:nvSpPr>
-        <p:spPr>
-          <a:xfrm>
-            <a:off x="825401" y="1117402"/>
-            <a:ext cx="7302716" cy="178296"/>
-          </a:xfrm>
-          <a:prstGeom prst="rect">
-            <a:avLst/>
-          </a:prstGeom>
-          <a:noFill/>
-          <a:ln/>
-        </p:spPr>
-        <p:txBody>
-          <a:bodyPr wrap="square" lIns="0" tIns="0" rIns="0" bIns="0" rtlCol="0" anchor="t"/>
-          <a:lstStyle/>
-          <a:p>
-            <a:pPr algn="l" indent="0" marL="0">
-              <a:lnSpc>
-                <a:spcPts val="1404"/>
-              </a:lnSpc>
-              <a:buNone/>
-            </a:pPr>
-            <a:r>
-              <a:rPr lang="en-US" sz="1080" b="1" dirty="0">
-                <a:solidFill>
-                  <a:srgbClr val="FFFFFF"/>
-                </a:solidFill>
-                <a:latin typeface="Arial" pitchFamily="34" charset="0"/>
-                <a:ea typeface="Arial" pitchFamily="34" charset="-122"/>
-                <a:cs typeface="Arial" pitchFamily="34" charset="-120"/>
-              </a:rPr>
-              <a:t>"It's provisioning" needs a status bar.</a:t>
-            </a:r>
-            <a:pPr algn="l" indent="0" marL="0">
-              <a:lnSpc>
-                <a:spcPts val="1404"/>
-              </a:lnSpc>
-              <a:buNone/>
-            </a:pPr>
-            <a:r>
-              <a:rPr lang="en-US" sz="1080" dirty="0">
-                <a:solidFill>
-                  <a:srgbClr val="CBD5E1"/>
-                </a:solidFill>
-                <a:latin typeface="Arial" pitchFamily="34" charset="0"/>
-                <a:ea typeface="Arial" pitchFamily="34" charset="-122"/>
-                <a:cs typeface="Arial" pitchFamily="34" charset="-120"/>
-              </a:rPr>
-              <a:t> A 5-minute cold start looks exactly like broken if the UI doesn't say otherwise.</a:t>
-            </a:r>
-            <a:endParaRPr lang="en-US" sz="1080" dirty="0"/>
-          </a:p>
-        </p:txBody>
-      </p:sp>
-      <p:pic>
-        <p:nvPicPr>
-          <p:cNvPr id="6" name="Image 1" descr="/tmp/claude-1000/-home-nodozi-projects-NEBIUS-MAR-2026-Nebius-serverless-llm-experiments-lab/c5359c07-1207-4b10-b30c-fa9e048bfd83/scratchpad/pptx/icons/cloud.png">    </p:cNvPr>
-          <p:cNvPicPr>
-            <a:picLocks noChangeAspect="1"/>
-          </p:cNvPicPr>
-          <p:nvPr/>
-        </p:nvPicPr>
-        <p:blipFill>
-          <a:blip r:embed="rId2"/>
-          <a:stretch>
-            <a:fillRect/>
-          </a:stretch>
-        </p:blipFill>
-        <p:spPr>
-          <a:xfrm>
-            <a:off x="507950" y="1460004"/>
-            <a:ext cx="190500" cy="190500"/>
-          </a:xfrm>
-          <a:prstGeom prst="rect">
-            <a:avLst/>
-          </a:prstGeom>
-        </p:spPr>
-      </p:pic>
-      <p:sp>
-        <p:nvSpPr>
-          <p:cNvPr id="7" name="Text 3"/>
-          <p:cNvSpPr/>
-          <p:nvPr/>
-        </p:nvSpPr>
-        <p:spPr>
-          <a:xfrm>
-            <a:off x="825401" y="1434703"/>
-            <a:ext cx="7966862" cy="356592"/>
-          </a:xfrm>
-          <a:prstGeom prst="rect">
-            <a:avLst/>
-          </a:prstGeom>
-          <a:noFill/>
-          <a:ln/>
-        </p:spPr>
-        <p:txBody>
-          <a:bodyPr wrap="square" lIns="0" tIns="0" rIns="0" bIns="0" rtlCol="0" anchor="t"/>
-          <a:lstStyle/>
-          <a:p>
-            <a:pPr algn="l" indent="0" marL="0">
-              <a:lnSpc>
-                <a:spcPts val="1404"/>
-              </a:lnSpc>
-              <a:buNone/>
-            </a:pPr>
-            <a:r>
-              <a:rPr lang="en-US" sz="1080" b="1" dirty="0">
-                <a:solidFill>
-                  <a:srgbClr val="FFFFFF"/>
-                </a:solidFill>
-                <a:latin typeface="Arial" pitchFamily="34" charset="0"/>
-                <a:ea typeface="Arial" pitchFamily="34" charset="-122"/>
-                <a:cs typeface="Arial" pitchFamily="34" charset="-120"/>
-              </a:rPr>
-              <a:t>CPU containers don't want CUDA along for the ride.</a:t>
-            </a:r>
-            <a:pPr algn="l" indent="0" marL="0">
-              <a:lnSpc>
-                <a:spcPts val="1404"/>
-              </a:lnSpc>
-              <a:buNone/>
-            </a:pPr>
-            <a:r>
-              <a:rPr lang="en-US" sz="1080" dirty="0">
-                <a:solidFill>
-                  <a:srgbClr val="CBD5E1"/>
-                </a:solidFill>
-                <a:latin typeface="Arial" pitchFamily="34" charset="0"/>
-                <a:ea typeface="Arial" pitchFamily="34" charset="-122"/>
-                <a:cs typeface="Arial" pitchFamily="34" charset="-120"/>
-              </a:rPr>
-              <a:t> Splitting the trainer image in two fixed it — obvious in hindsight, not obvious at 2am.</a:t>
-            </a:r>
-            <a:endParaRPr lang="en-US" sz="1080" dirty="0"/>
-          </a:p>
-        </p:txBody>
-      </p:sp>
-      <p:pic>
-        <p:nvPicPr>
-          <p:cNvPr id="8" name="Image 2" descr="/tmp/claude-1000/-home-nodozi-projects-NEBIUS-MAR-2026-Nebius-serverless-llm-experiments-lab/c5359c07-1207-4b10-b30c-fa9e048bfd83/scratchpad/pptx/icons/server.png">    </p:cNvPr>
+          <p:cNvPr id="4" name="Image 0" descr="/tmp/claude-1000/-home-nodozi-projects-NEBIUS-MAR-2026-Nebius-serverless-llm-experiments-lab/c5359c07-1207-4b10-b30c-fa9e048bfd83/scratchpad/pptx/icons/bug.png"/>
           <p:cNvPicPr>
             <a:picLocks noChangeAspect="1"/>
           </p:cNvPicPr>
@@ -5126,7 +3927,7 @@
         </p:blipFill>
         <p:spPr>
           <a:xfrm>
-            <a:off x="507950" y="1918097"/>
+            <a:off x="507950" y="1142702"/>
             <a:ext cx="190500" cy="190500"/>
           </a:xfrm>
           <a:prstGeom prst="rect">
@@ -5136,26 +3937,26 @@
       </p:pic>
       <p:sp>
         <p:nvSpPr>
-          <p:cNvPr id="9" name="Text 4"/>
-          <p:cNvSpPr/>
-          <p:nvPr/>
-        </p:nvSpPr>
-        <p:spPr>
-          <a:xfrm>
-            <a:off x="825401" y="1892796"/>
-            <a:ext cx="7966862" cy="356592"/>
-          </a:xfrm>
-          <a:prstGeom prst="rect">
-            <a:avLst/>
-          </a:prstGeom>
-          <a:noFill/>
-          <a:ln/>
-        </p:spPr>
-        <p:txBody>
-          <a:bodyPr wrap="square" lIns="0" tIns="0" rIns="0" bIns="0" rtlCol="0" anchor="t"/>
-          <a:lstStyle/>
-          <a:p>
-            <a:pPr algn="l" indent="0" marL="0">
+          <p:cNvPr id="5" name="Text 2"/>
+          <p:cNvSpPr/>
+          <p:nvPr/>
+        </p:nvSpPr>
+        <p:spPr>
+          <a:xfrm>
+            <a:off x="825401" y="1117402"/>
+            <a:ext cx="7302716" cy="178296"/>
+          </a:xfrm>
+          <a:prstGeom prst="rect">
+            <a:avLst/>
+          </a:prstGeom>
+          <a:noFill/>
+          <a:ln/>
+        </p:spPr>
+        <p:txBody>
+          <a:bodyPr wrap="square" lIns="0" tIns="0" rIns="0" bIns="0" rtlCol="0" anchor="t"/>
+          <a:lstStyle/>
+          <a:p>
+            <a:pPr marL="0" indent="0" algn="l">
               <a:lnSpc>
                 <a:spcPts val="1404"/>
               </a:lnSpc>
@@ -5170,14 +3971,8 @@
                 <a:ea typeface="Arial" pitchFamily="34" charset="-122"/>
                 <a:cs typeface="Arial" pitchFamily="34" charset="-120"/>
               </a:rPr>
-              <a:t>One shared endpoint is cheap and simple. It's also a ceiling.</a:t>
-            </a:r>
-            <a:pPr algn="l" indent="0" marL="0">
-              <a:lnSpc>
-                <a:spcPts val="1404"/>
-              </a:lnSpc>
-              <a:buNone/>
-            </a:pPr>
+              <a:t>"It's provisioning" needs a status bar.</a:t>
+            </a:r>
             <a:r>
               <a:rPr lang="en-US" sz="1080" dirty="0">
                 <a:solidFill>
@@ -5187,7 +3982,7 @@
                 <a:ea typeface="Arial" pitchFamily="34" charset="-122"/>
                 <a:cs typeface="Arial" pitchFamily="34" charset="-120"/>
               </a:rPr>
-              <a:t> Fine for a demo, needs queuing or hardware tiers before real concurrent users.</a:t>
+              <a:t> A 5-minute cold start looks exactly like broken if the UI doesn't say otherwise.</a:t>
             </a:r>
             <a:endParaRPr lang="en-US" sz="1080" dirty="0"/>
           </a:p>
@@ -5195,7 +3990,7 @@
       </p:sp>
       <p:pic>
         <p:nvPicPr>
-          <p:cNvPr id="10" name="Image 3" descr="/tmp/claude-1000/-home-nodozi-projects-NEBIUS-MAR-2026-Nebius-serverless-llm-experiments-lab/c5359c07-1207-4b10-b30c-fa9e048bfd83/scratchpad/pptx/icons/check.png">    </p:cNvPr>
+          <p:cNvPr id="6" name="Image 1" descr="/tmp/claude-1000/-home-nodozi-projects-NEBIUS-MAR-2026-Nebius-serverless-llm-experiments-lab/c5359c07-1207-4b10-b30c-fa9e048bfd83/scratchpad/pptx/icons/cloud.png"/>
           <p:cNvPicPr>
             <a:picLocks noChangeAspect="1"/>
           </p:cNvPicPr>
@@ -5209,7 +4004,7 @@
         </p:blipFill>
         <p:spPr>
           <a:xfrm>
-            <a:off x="507950" y="2376190"/>
+            <a:off x="507950" y="1460004"/>
             <a:ext cx="190500" cy="190500"/>
           </a:xfrm>
           <a:prstGeom prst="rect">
@@ -5219,26 +4014,26 @@
       </p:pic>
       <p:sp>
         <p:nvSpPr>
-          <p:cNvPr id="11" name="Text 5"/>
-          <p:cNvSpPr/>
-          <p:nvPr/>
-        </p:nvSpPr>
-        <p:spPr>
-          <a:xfrm>
-            <a:off x="825401" y="2350889"/>
-            <a:ext cx="7595244" cy="178296"/>
-          </a:xfrm>
-          <a:prstGeom prst="rect">
-            <a:avLst/>
-          </a:prstGeom>
-          <a:noFill/>
-          <a:ln/>
-        </p:spPr>
-        <p:txBody>
-          <a:bodyPr wrap="square" lIns="0" tIns="0" rIns="0" bIns="0" rtlCol="0" anchor="t"/>
-          <a:lstStyle/>
-          <a:p>
-            <a:pPr algn="l" indent="0" marL="0">
+          <p:cNvPr id="7" name="Text 3"/>
+          <p:cNvSpPr/>
+          <p:nvPr/>
+        </p:nvSpPr>
+        <p:spPr>
+          <a:xfrm>
+            <a:off x="825401" y="1434703"/>
+            <a:ext cx="7966862" cy="356592"/>
+          </a:xfrm>
+          <a:prstGeom prst="rect">
+            <a:avLst/>
+          </a:prstGeom>
+          <a:noFill/>
+          <a:ln/>
+        </p:spPr>
+        <p:txBody>
+          <a:bodyPr wrap="square" lIns="0" tIns="0" rIns="0" bIns="0" rtlCol="0" anchor="t"/>
+          <a:lstStyle/>
+          <a:p>
+            <a:pPr marL="0" indent="0" algn="l">
               <a:lnSpc>
                 <a:spcPts val="1404"/>
               </a:lnSpc>
@@ -5253,14 +4048,8 @@
                 <a:ea typeface="Arial" pitchFamily="34" charset="-122"/>
                 <a:cs typeface="Arial" pitchFamily="34" charset="-120"/>
               </a:rPr>
-              <a:t>The exact same off-by-one bug hid in two different fields.</a:t>
-            </a:r>
-            <a:pPr algn="l" indent="0" marL="0">
-              <a:lnSpc>
-                <a:spcPts val="1404"/>
-              </a:lnSpc>
-              <a:buNone/>
-            </a:pPr>
+              <a:t>CPU containers don't want CUDA along for the ride.</a:t>
+            </a:r>
             <a:r>
               <a:rPr lang="en-US" sz="1080" dirty="0">
                 <a:solidFill>
@@ -5270,7 +4059,7 @@
                 <a:ea typeface="Arial" pitchFamily="34" charset="-122"/>
                 <a:cs typeface="Arial" pitchFamily="34" charset="-120"/>
               </a:rPr>
-              <a:t> Testing discipline caught it — a "looks right" HTTP test didn't.</a:t>
+              <a:t> Splitting the trainer image in two fixed it — obvious in hindsight, not obvious at 2am.</a:t>
             </a:r>
             <a:endParaRPr lang="en-US" sz="1080" dirty="0"/>
           </a:p>
@@ -5278,7 +4067,7 @@
       </p:sp>
       <p:pic>
         <p:nvPicPr>
-          <p:cNvPr id="12" name="Image 4" descr="/tmp/claude-1000/-home-nodozi-projects-NEBIUS-MAR-2026-Nebius-serverless-llm-experiments-lab/c5359c07-1207-4b10-b30c-fa9e048bfd83/scratchpad/pptx/icons/lock.png">    </p:cNvPr>
+          <p:cNvPr id="8" name="Image 2" descr="/tmp/claude-1000/-home-nodozi-projects-NEBIUS-MAR-2026-Nebius-serverless-llm-experiments-lab/c5359c07-1207-4b10-b30c-fa9e048bfd83/scratchpad/pptx/icons/server.png"/>
           <p:cNvPicPr>
             <a:picLocks noChangeAspect="1"/>
           </p:cNvPicPr>
@@ -5292,7 +4081,7 @@
         </p:blipFill>
         <p:spPr>
           <a:xfrm>
-            <a:off x="507950" y="2693491"/>
+            <a:off x="507950" y="1918097"/>
             <a:ext cx="190500" cy="190500"/>
           </a:xfrm>
           <a:prstGeom prst="rect">
@@ -5302,13 +4091,13 @@
       </p:pic>
       <p:sp>
         <p:nvSpPr>
-          <p:cNvPr id="13" name="Text 6"/>
-          <p:cNvSpPr/>
-          <p:nvPr/>
-        </p:nvSpPr>
-        <p:spPr>
-          <a:xfrm>
-            <a:off x="825401" y="2668191"/>
+          <p:cNvPr id="9" name="Text 4"/>
+          <p:cNvSpPr/>
+          <p:nvPr/>
+        </p:nvSpPr>
+        <p:spPr>
+          <a:xfrm>
+            <a:off x="825401" y="1892796"/>
             <a:ext cx="7966862" cy="356592"/>
           </a:xfrm>
           <a:prstGeom prst="rect">
@@ -5321,7 +4110,7 @@
           <a:bodyPr wrap="square" lIns="0" tIns="0" rIns="0" bIns="0" rtlCol="0" anchor="t"/>
           <a:lstStyle/>
           <a:p>
-            <a:pPr algn="l" indent="0" marL="0">
+            <a:pPr marL="0" indent="0" algn="l">
               <a:lnSpc>
                 <a:spcPts val="1404"/>
               </a:lnSpc>
@@ -5336,14 +4125,8 @@
                 <a:ea typeface="Arial" pitchFamily="34" charset="-122"/>
                 <a:cs typeface="Arial" pitchFamily="34" charset="-120"/>
               </a:rPr>
-              <a:t>You can absolutely commit your own cloud account IDs to a public repo.</a:t>
-            </a:r>
-            <a:pPr algn="l" indent="0" marL="0">
-              <a:lnSpc>
-                <a:spcPts val="1404"/>
-              </a:lnSpc>
-              <a:buNone/>
-            </a:pPr>
+              <a:t>One shared endpoint is cheap and simple. It's also a ceiling.</a:t>
+            </a:r>
             <a:r>
               <a:rPr lang="en-US" sz="1080" dirty="0">
                 <a:solidFill>
@@ -5353,7 +4136,7 @@
                 <a:ea typeface="Arial" pitchFamily="34" charset="-122"/>
                 <a:cs typeface="Arial" pitchFamily="34" charset="-120"/>
               </a:rPr>
-              <a:t> History can be rewritten after the fact — better to just not.</a:t>
+              <a:t> Fine for a demo, needs queuing or hardware tiers before real concurrent users.</a:t>
             </a:r>
             <a:endParaRPr lang="en-US" sz="1080" dirty="0"/>
           </a:p>
@@ -5361,7 +4144,7 @@
       </p:sp>
       <p:pic>
         <p:nvPicPr>
-          <p:cNvPr id="14" name="Image 5" descr="/tmp/claude-1000/-home-nodozi-projects-NEBIUS-MAR-2026-Nebius-serverless-llm-experiments-lab/c5359c07-1207-4b10-b30c-fa9e048bfd83/scratchpad/pptx/icons/code.png">    </p:cNvPr>
+          <p:cNvPr id="12" name="Image 4" descr="/tmp/claude-1000/-home-nodozi-projects-NEBIUS-MAR-2026-Nebius-serverless-llm-experiments-lab/c5359c07-1207-4b10-b30c-fa9e048bfd83/scratchpad/pptx/icons/lock.png"/>
           <p:cNvPicPr>
             <a:picLocks noChangeAspect="1"/>
           </p:cNvPicPr>
@@ -5375,7 +4158,7 @@
         </p:blipFill>
         <p:spPr>
           <a:xfrm>
-            <a:off x="507950" y="3151584"/>
+            <a:off x="507950" y="2369203"/>
             <a:ext cx="190500" cy="190500"/>
           </a:xfrm>
           <a:prstGeom prst="rect">
@@ -5385,26 +4168,26 @@
       </p:pic>
       <p:sp>
         <p:nvSpPr>
-          <p:cNvPr id="15" name="Text 7"/>
-          <p:cNvSpPr/>
-          <p:nvPr/>
-        </p:nvSpPr>
-        <p:spPr>
-          <a:xfrm>
-            <a:off x="825401" y="3126284"/>
-            <a:ext cx="7966862" cy="534888"/>
-          </a:xfrm>
-          <a:prstGeom prst="rect">
-            <a:avLst/>
-          </a:prstGeom>
-          <a:noFill/>
-          <a:ln/>
-        </p:spPr>
-        <p:txBody>
-          <a:bodyPr wrap="square" lIns="0" tIns="0" rIns="0" bIns="0" rtlCol="0" anchor="t"/>
-          <a:lstStyle/>
-          <a:p>
-            <a:pPr algn="l" indent="0" marL="0">
+          <p:cNvPr id="13" name="Text 6"/>
+          <p:cNvSpPr/>
+          <p:nvPr/>
+        </p:nvSpPr>
+        <p:spPr>
+          <a:xfrm>
+            <a:off x="825401" y="2343903"/>
+            <a:ext cx="7966862" cy="356592"/>
+          </a:xfrm>
+          <a:prstGeom prst="rect">
+            <a:avLst/>
+          </a:prstGeom>
+          <a:noFill/>
+          <a:ln/>
+        </p:spPr>
+        <p:txBody>
+          <a:bodyPr wrap="square" lIns="0" tIns="0" rIns="0" bIns="0" rtlCol="0" anchor="t"/>
+          <a:lstStyle/>
+          <a:p>
+            <a:pPr marL="0" indent="0" algn="l">
               <a:lnSpc>
                 <a:spcPts val="1404"/>
               </a:lnSpc>
@@ -5419,14 +4202,85 @@
                 <a:ea typeface="Arial" pitchFamily="34" charset="-122"/>
                 <a:cs typeface="Arial" pitchFamily="34" charset="-120"/>
               </a:rPr>
-              <a:t>Frontend work eats time if it's not your thing.</a:t>
-            </a:r>
-            <a:pPr algn="l" indent="0" marL="0">
+              <a:t>You can absolutely commit your own cloud account IDs to a public repo.</a:t>
+            </a:r>
+            <a:r>
+              <a:rPr lang="en-US" sz="1080" dirty="0">
+                <a:solidFill>
+                  <a:srgbClr val="CBD5E1"/>
+                </a:solidFill>
+                <a:latin typeface="Arial" pitchFamily="34" charset="0"/>
+                <a:ea typeface="Arial" pitchFamily="34" charset="-122"/>
+                <a:cs typeface="Arial" pitchFamily="34" charset="-120"/>
+              </a:rPr>
+              <a:t> History can be rewritten after the fact — better to just not.</a:t>
+            </a:r>
+            <a:endParaRPr lang="en-US" sz="1080" dirty="0"/>
+          </a:p>
+        </p:txBody>
+      </p:sp>
+      <p:pic>
+        <p:nvPicPr>
+          <p:cNvPr id="14" name="Image 5" descr="/tmp/claude-1000/-home-nodozi-projects-NEBIUS-MAR-2026-Nebius-serverless-llm-experiments-lab/c5359c07-1207-4b10-b30c-fa9e048bfd83/scratchpad/pptx/icons/code.png"/>
+          <p:cNvPicPr>
+            <a:picLocks noChangeAspect="1"/>
+          </p:cNvPicPr>
+          <p:nvPr/>
+        </p:nvPicPr>
+        <p:blipFill>
+          <a:blip r:embed="rId7"/>
+          <a:stretch>
+            <a:fillRect/>
+          </a:stretch>
+        </p:blipFill>
+        <p:spPr>
+          <a:xfrm>
+            <a:off x="507950" y="2827296"/>
+            <a:ext cx="190500" cy="190500"/>
+          </a:xfrm>
+          <a:prstGeom prst="rect">
+            <a:avLst/>
+          </a:prstGeom>
+        </p:spPr>
+      </p:pic>
+      <p:sp>
+        <p:nvSpPr>
+          <p:cNvPr id="15" name="Text 7"/>
+          <p:cNvSpPr/>
+          <p:nvPr/>
+        </p:nvSpPr>
+        <p:spPr>
+          <a:xfrm>
+            <a:off x="825401" y="2801996"/>
+            <a:ext cx="7966862" cy="534888"/>
+          </a:xfrm>
+          <a:prstGeom prst="rect">
+            <a:avLst/>
+          </a:prstGeom>
+          <a:noFill/>
+          <a:ln/>
+        </p:spPr>
+        <p:txBody>
+          <a:bodyPr wrap="square" lIns="0" tIns="0" rIns="0" bIns="0" rtlCol="0" anchor="t"/>
+          <a:lstStyle/>
+          <a:p>
+            <a:pPr marL="0" indent="0" algn="l">
               <a:lnSpc>
                 <a:spcPts val="1404"/>
               </a:lnSpc>
               <a:buNone/>
             </a:pPr>
+            <a:r>
+              <a:rPr lang="en-US" sz="1080" b="1" dirty="0">
+                <a:solidFill>
+                  <a:srgbClr val="FFFFFF"/>
+                </a:solidFill>
+                <a:latin typeface="Arial" pitchFamily="34" charset="0"/>
+                <a:ea typeface="Arial" pitchFamily="34" charset="-122"/>
+                <a:cs typeface="Arial" pitchFamily="34" charset="-120"/>
+              </a:rPr>
+              <a:t>Frontend work eats time if it's not your thing.</a:t>
+            </a:r>
             <a:r>
               <a:rPr lang="en-US" sz="1080" dirty="0">
                 <a:solidFill>
@@ -5464,6 +4318,13 @@
             <a:prstDash val="solid"/>
           </a:ln>
         </p:spPr>
+        <p:txBody>
+          <a:bodyPr/>
+          <a:lstStyle/>
+          <a:p>
+            <a:endParaRPr lang="en-GB"/>
+          </a:p>
+        </p:txBody>
       </p:sp>
       <p:sp>
         <p:nvSpPr>
@@ -5486,7 +4347,7 @@
           <a:bodyPr wrap="square" lIns="0" tIns="0" rIns="0" bIns="0" rtlCol="0" anchor="t"/>
           <a:lstStyle/>
           <a:p>
-            <a:pPr algn="l" indent="0" marL="0">
+            <a:pPr marL="0" indent="0" algn="l">
               <a:lnSpc>
                 <a:spcPts val="1820"/>
               </a:lnSpc>
@@ -5808,4 +4669,319 @@
     </a:ext>
   </a:extLst>
 </a:theme>
+</file>
+
+<file path=ppt/theme/theme2.xml><?xml version="1.0" encoding="utf-8"?>
+<a:theme xmlns:a="http://schemas.openxmlformats.org/drawingml/2006/main" name="Office Theme">
+  <a:themeElements>
+    <a:clrScheme name="Office">
+      <a:dk1>
+        <a:sysClr val="windowText" lastClr="000000"/>
+      </a:dk1>
+      <a:lt1>
+        <a:sysClr val="window" lastClr="FFFFFF"/>
+      </a:lt1>
+      <a:dk2>
+        <a:srgbClr val="0E2841"/>
+      </a:dk2>
+      <a:lt2>
+        <a:srgbClr val="E8E8E8"/>
+      </a:lt2>
+      <a:accent1>
+        <a:srgbClr val="156082"/>
+      </a:accent1>
+      <a:accent2>
+        <a:srgbClr val="E97132"/>
+      </a:accent2>
+      <a:accent3>
+        <a:srgbClr val="196B24"/>
+      </a:accent3>
+      <a:accent4>
+        <a:srgbClr val="0F9ED5"/>
+      </a:accent4>
+      <a:accent5>
+        <a:srgbClr val="A02B93"/>
+      </a:accent5>
+      <a:accent6>
+        <a:srgbClr val="4EA72E"/>
+      </a:accent6>
+      <a:hlink>
+        <a:srgbClr val="467886"/>
+      </a:hlink>
+      <a:folHlink>
+        <a:srgbClr val="96607D"/>
+      </a:folHlink>
+    </a:clrScheme>
+    <a:fontScheme name="Office">
+      <a:majorFont>
+        <a:latin typeface="Aptos Display" panose="02110004020202020204"/>
+        <a:ea typeface=""/>
+        <a:cs typeface=""/>
+        <a:font script="Jpan" typeface="游ゴシック Light"/>
+        <a:font script="Hang" typeface="맑은 고딕"/>
+        <a:font script="Hans" typeface="等线 Light"/>
+        <a:font script="Hant" typeface="新細明體"/>
+        <a:font script="Arab" typeface="Times New Roman"/>
+        <a:font script="Hebr" typeface="Times New Roman"/>
+        <a:font script="Thai" typeface="Angsana New"/>
+        <a:font script="Ethi" typeface="Nyala"/>
+        <a:font script="Beng" typeface="Vrinda"/>
+        <a:font script="Gujr" typeface="Shruti"/>
+        <a:font script="Khmr" typeface="MoolBoran"/>
+        <a:font script="Knda" typeface="Tunga"/>
+        <a:font script="Guru" typeface="Raavi"/>
+        <a:font script="Cans" typeface="Euphemia"/>
+        <a:font script="Cher" typeface="Plantagenet Cherokee"/>
+        <a:font script="Yiii" typeface="Microsoft Yi Baiti"/>
+        <a:font script="Tibt" typeface="Microsoft Himalaya"/>
+        <a:font script="Thaa" typeface="MV Boli"/>
+        <a:font script="Deva" typeface="Mangal"/>
+        <a:font script="Telu" typeface="Gautami"/>
+        <a:font script="Taml" typeface="Latha"/>
+        <a:font script="Syrc" typeface="Estrangelo Edessa"/>
+        <a:font script="Orya" typeface="Kalinga"/>
+        <a:font script="Mlym" typeface="Kartika"/>
+        <a:font script="Laoo" typeface="DokChampa"/>
+        <a:font script="Sinh" typeface="Iskoola Pota"/>
+        <a:font script="Mong" typeface="Mongolian Baiti"/>
+        <a:font script="Viet" typeface="Times New Roman"/>
+        <a:font script="Uigh" typeface="Microsoft Uighur"/>
+        <a:font script="Geor" typeface="Sylfaen"/>
+        <a:font script="Armn" typeface="Arial"/>
+        <a:font script="Bugi" typeface="Leelawadee UI"/>
+        <a:font script="Bopo" typeface="Microsoft JhengHei"/>
+        <a:font script="Java" typeface="Javanese Text"/>
+        <a:font script="Lisu" typeface="Segoe UI"/>
+        <a:font script="Mymr" typeface="Myanmar Text"/>
+        <a:font script="Nkoo" typeface="Ebrima"/>
+        <a:font script="Olck" typeface="Nirmala UI"/>
+        <a:font script="Osma" typeface="Ebrima"/>
+        <a:font script="Phag" typeface="Phagspa"/>
+        <a:font script="Syrn" typeface="Estrangelo Edessa"/>
+        <a:font script="Syrj" typeface="Estrangelo Edessa"/>
+        <a:font script="Syre" typeface="Estrangelo Edessa"/>
+        <a:font script="Sora" typeface="Nirmala UI"/>
+        <a:font script="Tale" typeface="Microsoft Tai Le"/>
+        <a:font script="Talu" typeface="Microsoft New Tai Lue"/>
+        <a:font script="Tfng" typeface="Ebrima"/>
+      </a:majorFont>
+      <a:minorFont>
+        <a:latin typeface="Aptos" panose="02110004020202020204"/>
+        <a:ea typeface=""/>
+        <a:cs typeface=""/>
+        <a:font script="Jpan" typeface="游ゴシック"/>
+        <a:font script="Hang" typeface="맑은 고딕"/>
+        <a:font script="Hans" typeface="等线"/>
+        <a:font script="Hant" typeface="新細明體"/>
+        <a:font script="Arab" typeface="Arial"/>
+        <a:font script="Hebr" typeface="Arial"/>
+        <a:font script="Thai" typeface="Cordia New"/>
+        <a:font script="Ethi" typeface="Nyala"/>
+        <a:font script="Beng" typeface="Vrinda"/>
+        <a:font script="Gujr" typeface="Shruti"/>
+        <a:font script="Khmr" typeface="DaunPenh"/>
+        <a:font script="Knda" typeface="Tunga"/>
+        <a:font script="Guru" typeface="Raavi"/>
+        <a:font script="Cans" typeface="Euphemia"/>
+        <a:font script="Cher" typeface="Plantagenet Cherokee"/>
+        <a:font script="Yiii" typeface="Microsoft Yi Baiti"/>
+        <a:font script="Tibt" typeface="Microsoft Himalaya"/>
+        <a:font script="Thaa" typeface="MV Boli"/>
+        <a:font script="Deva" typeface="Mangal"/>
+        <a:font script="Telu" typeface="Gautami"/>
+        <a:font script="Taml" typeface="Latha"/>
+        <a:font script="Syrc" typeface="Estrangelo Edessa"/>
+        <a:font script="Orya" typeface="Kalinga"/>
+        <a:font script="Mlym" typeface="Kartika"/>
+        <a:font script="Laoo" typeface="DokChampa"/>
+        <a:font script="Sinh" typeface="Iskoola Pota"/>
+        <a:font script="Mong" typeface="Mongolian Baiti"/>
+        <a:font script="Viet" typeface="Arial"/>
+        <a:font script="Uigh" typeface="Microsoft Uighur"/>
+        <a:font script="Geor" typeface="Sylfaen"/>
+        <a:font script="Armn" typeface="Arial"/>
+        <a:font script="Bugi" typeface="Leelawadee UI"/>
+        <a:font script="Bopo" typeface="Microsoft JhengHei"/>
+        <a:font script="Java" typeface="Javanese Text"/>
+        <a:font script="Lisu" typeface="Segoe UI"/>
+        <a:font script="Mymr" typeface="Myanmar Text"/>
+        <a:font script="Nkoo" typeface="Ebrima"/>
+        <a:font script="Olck" typeface="Nirmala UI"/>
+        <a:font script="Osma" typeface="Ebrima"/>
+        <a:font script="Phag" typeface="Phagspa"/>
+        <a:font script="Syrn" typeface="Estrangelo Edessa"/>
+        <a:font script="Syrj" typeface="Estrangelo Edessa"/>
+        <a:font script="Syre" typeface="Estrangelo Edessa"/>
+        <a:font script="Sora" typeface="Nirmala UI"/>
+        <a:font script="Tale" typeface="Microsoft Tai Le"/>
+        <a:font script="Talu" typeface="Microsoft New Tai Lue"/>
+        <a:font script="Tfng" typeface="Ebrima"/>
+      </a:minorFont>
+    </a:fontScheme>
+    <a:fmtScheme name="Office">
+      <a:fillStyleLst>
+        <a:solidFill>
+          <a:schemeClr val="phClr"/>
+        </a:solidFill>
+        <a:gradFill rotWithShape="1">
+          <a:gsLst>
+            <a:gs pos="0">
+              <a:schemeClr val="phClr">
+                <a:lumMod val="110000"/>
+                <a:satMod val="105000"/>
+                <a:tint val="67000"/>
+              </a:schemeClr>
+            </a:gs>
+            <a:gs pos="50000">
+              <a:schemeClr val="phClr">
+                <a:lumMod val="105000"/>
+                <a:satMod val="103000"/>
+                <a:tint val="73000"/>
+              </a:schemeClr>
+            </a:gs>
+            <a:gs pos="100000">
+              <a:schemeClr val="phClr">
+                <a:lumMod val="105000"/>
+                <a:satMod val="109000"/>
+                <a:tint val="81000"/>
+              </a:schemeClr>
+            </a:gs>
+          </a:gsLst>
+          <a:lin ang="5400000" scaled="0"/>
+        </a:gradFill>
+        <a:gradFill rotWithShape="1">
+          <a:gsLst>
+            <a:gs pos="0">
+              <a:schemeClr val="phClr">
+                <a:satMod val="103000"/>
+                <a:lumMod val="102000"/>
+                <a:tint val="94000"/>
+              </a:schemeClr>
+            </a:gs>
+            <a:gs pos="50000">
+              <a:schemeClr val="phClr">
+                <a:satMod val="110000"/>
+                <a:lumMod val="100000"/>
+                <a:shade val="100000"/>
+              </a:schemeClr>
+            </a:gs>
+            <a:gs pos="100000">
+              <a:schemeClr val="phClr">
+                <a:lumMod val="99000"/>
+                <a:satMod val="120000"/>
+                <a:shade val="78000"/>
+              </a:schemeClr>
+            </a:gs>
+          </a:gsLst>
+          <a:lin ang="5400000" scaled="0"/>
+        </a:gradFill>
+      </a:fillStyleLst>
+      <a:lnStyleLst>
+        <a:ln w="12700" cap="flat" cmpd="sng" algn="ctr">
+          <a:solidFill>
+            <a:schemeClr val="phClr"/>
+          </a:solidFill>
+          <a:prstDash val="solid"/>
+          <a:miter lim="800000"/>
+        </a:ln>
+        <a:ln w="19050" cap="flat" cmpd="sng" algn="ctr">
+          <a:solidFill>
+            <a:schemeClr val="phClr"/>
+          </a:solidFill>
+          <a:prstDash val="solid"/>
+          <a:miter lim="800000"/>
+        </a:ln>
+        <a:ln w="25400" cap="flat" cmpd="sng" algn="ctr">
+          <a:solidFill>
+            <a:schemeClr val="phClr"/>
+          </a:solidFill>
+          <a:prstDash val="solid"/>
+          <a:miter lim="800000"/>
+        </a:ln>
+      </a:lnStyleLst>
+      <a:effectStyleLst>
+        <a:effectStyle>
+          <a:effectLst/>
+        </a:effectStyle>
+        <a:effectStyle>
+          <a:effectLst/>
+        </a:effectStyle>
+        <a:effectStyle>
+          <a:effectLst>
+            <a:outerShdw blurRad="57150" dist="19050" dir="5400000" algn="ctr" rotWithShape="0">
+              <a:srgbClr val="000000">
+                <a:alpha val="63000"/>
+              </a:srgbClr>
+            </a:outerShdw>
+          </a:effectLst>
+        </a:effectStyle>
+      </a:effectStyleLst>
+      <a:bgFillStyleLst>
+        <a:solidFill>
+          <a:schemeClr val="phClr"/>
+        </a:solidFill>
+        <a:solidFill>
+          <a:schemeClr val="phClr">
+            <a:tint val="95000"/>
+            <a:satMod val="170000"/>
+          </a:schemeClr>
+        </a:solidFill>
+        <a:gradFill rotWithShape="1">
+          <a:gsLst>
+            <a:gs pos="0">
+              <a:schemeClr val="phClr">
+                <a:tint val="93000"/>
+                <a:satMod val="150000"/>
+                <a:shade val="98000"/>
+                <a:lumMod val="102000"/>
+              </a:schemeClr>
+            </a:gs>
+            <a:gs pos="50000">
+              <a:schemeClr val="phClr">
+                <a:tint val="98000"/>
+                <a:satMod val="130000"/>
+                <a:shade val="90000"/>
+                <a:lumMod val="103000"/>
+              </a:schemeClr>
+            </a:gs>
+            <a:gs pos="100000">
+              <a:schemeClr val="phClr">
+                <a:shade val="63000"/>
+                <a:satMod val="120000"/>
+              </a:schemeClr>
+            </a:gs>
+          </a:gsLst>
+          <a:lin ang="5400000" scaled="0"/>
+        </a:gradFill>
+      </a:bgFillStyleLst>
+    </a:fmtScheme>
+  </a:themeElements>
+  <a:objectDefaults>
+    <a:lnDef>
+      <a:spPr/>
+      <a:bodyPr/>
+      <a:lstStyle/>
+      <a:style>
+        <a:lnRef idx="2">
+          <a:schemeClr val="accent1"/>
+        </a:lnRef>
+        <a:fillRef idx="0">
+          <a:schemeClr val="accent1"/>
+        </a:fillRef>
+        <a:effectRef idx="1">
+          <a:schemeClr val="accent1"/>
+        </a:effectRef>
+        <a:fontRef idx="minor">
+          <a:schemeClr val="tx1"/>
+        </a:fontRef>
+      </a:style>
+    </a:lnDef>
+  </a:objectDefaults>
+  <a:extraClrSchemeLst/>
+  <a:extLst>
+    <a:ext uri="{05A4C25C-085E-4340-85A3-A5531E510DB2}">
+      <thm15:themeFamily xmlns:thm15="http://schemas.microsoft.com/office/thememl/2012/main" name="Office Theme" id="{2E142A2C-CD16-42D6-873A-C26D2A0506FA}" vid="{1BDDFF52-6CD6-40A5-AB3C-68EB2F1E4D0A}"/>
+    </a:ext>
+  </a:extLst>
+</a:theme>
 </file>
</xml_diff>